<commit_message>
Updated 06/Trade + Created 08/Barganing (in progress)
</commit_message>
<xml_diff>
--- a/figs/DIYfigures_ipe1.pptx
+++ b/figs/DIYfigures_ipe1.pptx
@@ -10,6 +10,10 @@
     <p:sldId id="259" r:id="rId4"/>
     <p:sldId id="260" r:id="rId5"/>
     <p:sldId id="261" r:id="rId6"/>
+    <p:sldId id="263" r:id="rId7"/>
+    <p:sldId id="262" r:id="rId8"/>
+    <p:sldId id="264" r:id="rId9"/>
+    <p:sldId id="265" r:id="rId10"/>
   </p:sldIdLst>
   <p:sldSz cx="12192000" cy="6858000"/>
   <p:notesSz cx="6858000" cy="9144000"/>
@@ -3765,7 +3769,7 @@
           <a:p>
             <a:fld id="{29D38AE0-A022-EC4B-ADED-C3987264F154}" type="datetimeFigureOut">
               <a:rPr kumimoji="1" lang="ja-JP" altLang="en-US" smtClean="0"/>
-              <a:t>2026/4/29</a:t>
+              <a:t>2026/5/25</a:t>
             </a:fld>
             <a:endParaRPr kumimoji="1" lang="ja-JP" altLang="en-US"/>
           </a:p>
@@ -3995,7 +3999,7 @@
           <a:p>
             <a:fld id="{29D38AE0-A022-EC4B-ADED-C3987264F154}" type="datetimeFigureOut">
               <a:rPr kumimoji="1" lang="ja-JP" altLang="en-US" smtClean="0"/>
-              <a:t>2026/4/29</a:t>
+              <a:t>2026/5/25</a:t>
             </a:fld>
             <a:endParaRPr kumimoji="1" lang="ja-JP" altLang="en-US"/>
           </a:p>
@@ -4235,7 +4239,7 @@
           <a:p>
             <a:fld id="{29D38AE0-A022-EC4B-ADED-C3987264F154}" type="datetimeFigureOut">
               <a:rPr kumimoji="1" lang="ja-JP" altLang="en-US" smtClean="0"/>
-              <a:t>2026/4/29</a:t>
+              <a:t>2026/5/25</a:t>
             </a:fld>
             <a:endParaRPr kumimoji="1" lang="ja-JP" altLang="en-US"/>
           </a:p>
@@ -4465,7 +4469,7 @@
           <a:p>
             <a:fld id="{29D38AE0-A022-EC4B-ADED-C3987264F154}" type="datetimeFigureOut">
               <a:rPr kumimoji="1" lang="ja-JP" altLang="en-US" smtClean="0"/>
-              <a:t>2026/4/29</a:t>
+              <a:t>2026/5/25</a:t>
             </a:fld>
             <a:endParaRPr kumimoji="1" lang="ja-JP" altLang="en-US"/>
           </a:p>
@@ -4740,7 +4744,7 @@
           <a:p>
             <a:fld id="{29D38AE0-A022-EC4B-ADED-C3987264F154}" type="datetimeFigureOut">
               <a:rPr kumimoji="1" lang="ja-JP" altLang="en-US" smtClean="0"/>
-              <a:t>2026/4/29</a:t>
+              <a:t>2026/5/25</a:t>
             </a:fld>
             <a:endParaRPr kumimoji="1" lang="ja-JP" altLang="en-US"/>
           </a:p>
@@ -5069,7 +5073,7 @@
           <a:p>
             <a:fld id="{29D38AE0-A022-EC4B-ADED-C3987264F154}" type="datetimeFigureOut">
               <a:rPr kumimoji="1" lang="ja-JP" altLang="en-US" smtClean="0"/>
-              <a:t>2026/4/29</a:t>
+              <a:t>2026/5/25</a:t>
             </a:fld>
             <a:endParaRPr kumimoji="1" lang="ja-JP" altLang="en-US"/>
           </a:p>
@@ -5545,7 +5549,7 @@
           <a:p>
             <a:fld id="{29D38AE0-A022-EC4B-ADED-C3987264F154}" type="datetimeFigureOut">
               <a:rPr kumimoji="1" lang="ja-JP" altLang="en-US" smtClean="0"/>
-              <a:t>2026/4/29</a:t>
+              <a:t>2026/5/25</a:t>
             </a:fld>
             <a:endParaRPr kumimoji="1" lang="ja-JP" altLang="en-US"/>
           </a:p>
@@ -5686,7 +5690,7 @@
           <a:p>
             <a:fld id="{29D38AE0-A022-EC4B-ADED-C3987264F154}" type="datetimeFigureOut">
               <a:rPr kumimoji="1" lang="ja-JP" altLang="en-US" smtClean="0"/>
-              <a:t>2026/4/29</a:t>
+              <a:t>2026/5/25</a:t>
             </a:fld>
             <a:endParaRPr kumimoji="1" lang="ja-JP" altLang="en-US"/>
           </a:p>
@@ -5799,7 +5803,7 @@
           <a:p>
             <a:fld id="{29D38AE0-A022-EC4B-ADED-C3987264F154}" type="datetimeFigureOut">
               <a:rPr kumimoji="1" lang="ja-JP" altLang="en-US" smtClean="0"/>
-              <a:t>2026/4/29</a:t>
+              <a:t>2026/5/25</a:t>
             </a:fld>
             <a:endParaRPr kumimoji="1" lang="ja-JP" altLang="en-US"/>
           </a:p>
@@ -6142,7 +6146,7 @@
           <a:p>
             <a:fld id="{29D38AE0-A022-EC4B-ADED-C3987264F154}" type="datetimeFigureOut">
               <a:rPr kumimoji="1" lang="ja-JP" altLang="en-US" smtClean="0"/>
-              <a:t>2026/4/29</a:t>
+              <a:t>2026/5/25</a:t>
             </a:fld>
             <a:endParaRPr kumimoji="1" lang="ja-JP" altLang="en-US"/>
           </a:p>
@@ -6430,7 +6434,7 @@
           <a:p>
             <a:fld id="{29D38AE0-A022-EC4B-ADED-C3987264F154}" type="datetimeFigureOut">
               <a:rPr kumimoji="1" lang="ja-JP" altLang="en-US" smtClean="0"/>
-              <a:t>2026/4/29</a:t>
+              <a:t>2026/5/25</a:t>
             </a:fld>
             <a:endParaRPr kumimoji="1" lang="ja-JP" altLang="en-US"/>
           </a:p>
@@ -6703,7 +6707,7 @@
           <a:p>
             <a:fld id="{29D38AE0-A022-EC4B-ADED-C3987264F154}" type="datetimeFigureOut">
               <a:rPr kumimoji="1" lang="ja-JP" altLang="en-US" smtClean="0"/>
-              <a:t>2026/4/29</a:t>
+              <a:t>2026/5/25</a:t>
             </a:fld>
             <a:endParaRPr kumimoji="1" lang="ja-JP" altLang="en-US"/>
           </a:p>
@@ -12496,6 +12500,4005 @@
 </p:sld>
 </file>
 
+<file path=ppt/slides/slide6.xml><?xml version="1.0" encoding="utf-8"?>
+<p:sld xmlns:a="http://schemas.openxmlformats.org/drawingml/2006/main" xmlns:r="http://schemas.openxmlformats.org/officeDocument/2006/relationships" xmlns:p="http://schemas.openxmlformats.org/presentationml/2006/main">
+  <p:cSld>
+    <p:spTree>
+      <p:nvGrpSpPr>
+        <p:cNvPr id="1" name=""/>
+        <p:cNvGrpSpPr/>
+        <p:nvPr/>
+      </p:nvGrpSpPr>
+      <p:grpSpPr>
+        <a:xfrm>
+          <a:off x="0" y="0"/>
+          <a:ext cx="0" cy="0"/>
+          <a:chOff x="0" y="0"/>
+          <a:chExt cx="0" cy="0"/>
+        </a:xfrm>
+      </p:grpSpPr>
+      <p:grpSp>
+        <p:nvGrpSpPr>
+          <p:cNvPr id="2" name="グループ化 1">
+            <a:extLst>
+              <a:ext uri="{FF2B5EF4-FFF2-40B4-BE49-F238E27FC236}">
+                <a16:creationId xmlns:a16="http://schemas.microsoft.com/office/drawing/2014/main" id="{DE2C9751-1CBE-6F75-3A0E-B1B815D4585A}"/>
+              </a:ext>
+            </a:extLst>
+          </p:cNvPr>
+          <p:cNvGrpSpPr/>
+          <p:nvPr/>
+        </p:nvGrpSpPr>
+        <p:grpSpPr>
+          <a:xfrm>
+            <a:off x="766152" y="390292"/>
+            <a:ext cx="9994775" cy="6304768"/>
+            <a:chOff x="766152" y="390292"/>
+            <a:chExt cx="9994775" cy="6304768"/>
+          </a:xfrm>
+        </p:grpSpPr>
+        <p:cxnSp>
+          <p:nvCxnSpPr>
+            <p:cNvPr id="3" name="直線矢印コネクタ 2">
+              <a:extLst>
+                <a:ext uri="{FF2B5EF4-FFF2-40B4-BE49-F238E27FC236}">
+                  <a16:creationId xmlns:a16="http://schemas.microsoft.com/office/drawing/2014/main" id="{5D974A56-BE31-F991-3AB0-48BB409C0071}"/>
+                </a:ext>
+              </a:extLst>
+            </p:cNvPr>
+            <p:cNvCxnSpPr>
+              <a:cxnSpLocks/>
+            </p:cNvCxnSpPr>
+            <p:nvPr/>
+          </p:nvCxnSpPr>
+          <p:spPr>
+            <a:xfrm>
+              <a:off x="1320150" y="6216979"/>
+              <a:ext cx="9440777" cy="0"/>
+            </a:xfrm>
+            <a:prstGeom prst="straightConnector1">
+              <a:avLst/>
+            </a:prstGeom>
+            <a:ln w="28575">
+              <a:solidFill>
+                <a:schemeClr val="tx1"/>
+              </a:solidFill>
+              <a:tailEnd type="triangle"/>
+            </a:ln>
+          </p:spPr>
+          <p:style>
+            <a:lnRef idx="1">
+              <a:schemeClr val="accent1"/>
+            </a:lnRef>
+            <a:fillRef idx="0">
+              <a:schemeClr val="accent1"/>
+            </a:fillRef>
+            <a:effectRef idx="0">
+              <a:schemeClr val="accent1"/>
+            </a:effectRef>
+            <a:fontRef idx="minor">
+              <a:schemeClr val="tx1"/>
+            </a:fontRef>
+          </p:style>
+        </p:cxnSp>
+        <p:cxnSp>
+          <p:nvCxnSpPr>
+            <p:cNvPr id="4" name="直線矢印コネクタ 3">
+              <a:extLst>
+                <a:ext uri="{FF2B5EF4-FFF2-40B4-BE49-F238E27FC236}">
+                  <a16:creationId xmlns:a16="http://schemas.microsoft.com/office/drawing/2014/main" id="{1C121E92-E783-AFAE-BA62-4111B1CBB6FE}"/>
+                </a:ext>
+              </a:extLst>
+            </p:cNvPr>
+            <p:cNvCxnSpPr>
+              <a:cxnSpLocks/>
+            </p:cNvCxnSpPr>
+            <p:nvPr/>
+          </p:nvCxnSpPr>
+          <p:spPr>
+            <a:xfrm flipV="1">
+              <a:off x="1320150" y="390293"/>
+              <a:ext cx="0" cy="5826686"/>
+            </a:xfrm>
+            <a:prstGeom prst="straightConnector1">
+              <a:avLst/>
+            </a:prstGeom>
+            <a:ln w="28575">
+              <a:solidFill>
+                <a:schemeClr val="tx1"/>
+              </a:solidFill>
+              <a:tailEnd type="triangle"/>
+            </a:ln>
+          </p:spPr>
+          <p:style>
+            <a:lnRef idx="1">
+              <a:schemeClr val="accent1"/>
+            </a:lnRef>
+            <a:fillRef idx="0">
+              <a:schemeClr val="accent1"/>
+            </a:fillRef>
+            <a:effectRef idx="0">
+              <a:schemeClr val="accent1"/>
+            </a:effectRef>
+            <a:fontRef idx="minor">
+              <a:schemeClr val="tx1"/>
+            </a:fontRef>
+          </p:style>
+        </p:cxnSp>
+        <p:sp>
+          <p:nvSpPr>
+            <p:cNvPr id="5" name="テキスト ボックス 4">
+              <a:extLst>
+                <a:ext uri="{FF2B5EF4-FFF2-40B4-BE49-F238E27FC236}">
+                  <a16:creationId xmlns:a16="http://schemas.microsoft.com/office/drawing/2014/main" id="{FF810532-EDE3-6DE0-72BA-7387C86A936D}"/>
+                </a:ext>
+              </a:extLst>
+            </p:cNvPr>
+            <p:cNvSpPr txBox="1"/>
+            <p:nvPr/>
+          </p:nvSpPr>
+          <p:spPr>
+            <a:xfrm>
+              <a:off x="9248061" y="6233395"/>
+              <a:ext cx="1512866" cy="461665"/>
+            </a:xfrm>
+            <a:prstGeom prst="rect">
+              <a:avLst/>
+            </a:prstGeom>
+            <a:noFill/>
+          </p:spPr>
+          <p:txBody>
+            <a:bodyPr wrap="square" rtlCol="0">
+              <a:spAutoFit/>
+            </a:bodyPr>
+            <a:lstStyle/>
+            <a:p>
+              <a:pPr algn="ctr"/>
+              <a:r>
+                <a:rPr kumimoji="1" lang="ja-JP" altLang="en-US" sz="2400">
+                  <a:latin typeface="Hiragino Kaku Gothic StdN W8" panose="020B0800000000000000" pitchFamily="34" charset="-128"/>
+                  <a:ea typeface="Hiragino Kaku Gothic StdN W8" panose="020B0800000000000000" pitchFamily="34" charset="-128"/>
+                </a:rPr>
+                <a:t>車関税率</a:t>
+              </a:r>
+            </a:p>
+          </p:txBody>
+        </p:sp>
+        <p:sp>
+          <p:nvSpPr>
+            <p:cNvPr id="6" name="テキスト ボックス 5">
+              <a:extLst>
+                <a:ext uri="{FF2B5EF4-FFF2-40B4-BE49-F238E27FC236}">
+                  <a16:creationId xmlns:a16="http://schemas.microsoft.com/office/drawing/2014/main" id="{6520EFE3-8F6F-F8FD-0B1A-55AB9411BDF6}"/>
+                </a:ext>
+              </a:extLst>
+            </p:cNvPr>
+            <p:cNvSpPr txBox="1"/>
+            <p:nvPr/>
+          </p:nvSpPr>
+          <p:spPr>
+            <a:xfrm>
+              <a:off x="766152" y="390292"/>
+              <a:ext cx="553998" cy="1323439"/>
+            </a:xfrm>
+            <a:prstGeom prst="rect">
+              <a:avLst/>
+            </a:prstGeom>
+            <a:noFill/>
+          </p:spPr>
+          <p:txBody>
+            <a:bodyPr vert="eaVert" wrap="none" rtlCol="0">
+              <a:spAutoFit/>
+            </a:bodyPr>
+            <a:lstStyle/>
+            <a:p>
+              <a:r>
+                <a:rPr kumimoji="1" lang="ja-JP" altLang="en-US" sz="2400">
+                  <a:latin typeface="Hiragino Kaku Gothic StdN W8" panose="020B0800000000000000" pitchFamily="34" charset="-128"/>
+                  <a:ea typeface="Hiragino Kaku Gothic StdN W8" panose="020B0800000000000000" pitchFamily="34" charset="-128"/>
+                </a:rPr>
+                <a:t>肉関税率</a:t>
+              </a:r>
+            </a:p>
+          </p:txBody>
+        </p:sp>
+        <p:grpSp>
+          <p:nvGrpSpPr>
+            <p:cNvPr id="11" name="グループ化 10">
+              <a:extLst>
+                <a:ext uri="{FF2B5EF4-FFF2-40B4-BE49-F238E27FC236}">
+                  <a16:creationId xmlns:a16="http://schemas.microsoft.com/office/drawing/2014/main" id="{4E1AEB85-1349-32C4-F02E-23263C73DE24}"/>
+                </a:ext>
+              </a:extLst>
+            </p:cNvPr>
+            <p:cNvGrpSpPr/>
+            <p:nvPr/>
+          </p:nvGrpSpPr>
+          <p:grpSpPr>
+            <a:xfrm>
+              <a:off x="2354479" y="390292"/>
+              <a:ext cx="4180231" cy="4180231"/>
+              <a:chOff x="1930271" y="273182"/>
+              <a:chExt cx="4180231" cy="4180231"/>
+            </a:xfrm>
+          </p:grpSpPr>
+          <p:sp>
+            <p:nvSpPr>
+              <p:cNvPr id="21" name="円/楕円 20">
+                <a:extLst>
+                  <a:ext uri="{FF2B5EF4-FFF2-40B4-BE49-F238E27FC236}">
+                    <a16:creationId xmlns:a16="http://schemas.microsoft.com/office/drawing/2014/main" id="{32BFC14F-9012-DF12-D0A5-22BC6E45FCE6}"/>
+                  </a:ext>
+                </a:extLst>
+              </p:cNvPr>
+              <p:cNvSpPr/>
+              <p:nvPr/>
+            </p:nvSpPr>
+            <p:spPr>
+              <a:xfrm>
+                <a:off x="3945487" y="2247163"/>
+                <a:ext cx="186550" cy="186550"/>
+              </a:xfrm>
+              <a:prstGeom prst="ellipse">
+                <a:avLst/>
+              </a:prstGeom>
+              <a:solidFill>
+                <a:schemeClr val="tx1"/>
+              </a:solidFill>
+              <a:ln>
+                <a:noFill/>
+              </a:ln>
+            </p:spPr>
+            <p:style>
+              <a:lnRef idx="2">
+                <a:schemeClr val="accent1">
+                  <a:shade val="50000"/>
+                </a:schemeClr>
+              </a:lnRef>
+              <a:fillRef idx="1">
+                <a:schemeClr val="accent1"/>
+              </a:fillRef>
+              <a:effectRef idx="0">
+                <a:schemeClr val="accent1"/>
+              </a:effectRef>
+              <a:fontRef idx="minor">
+                <a:schemeClr val="lt1"/>
+              </a:fontRef>
+            </p:style>
+            <p:txBody>
+              <a:bodyPr rtlCol="0" anchor="ctr"/>
+              <a:lstStyle/>
+              <a:p>
+                <a:pPr algn="ctr"/>
+                <a:endParaRPr kumimoji="1" lang="ja-JP" altLang="en-US"/>
+              </a:p>
+            </p:txBody>
+          </p:sp>
+          <p:sp>
+            <p:nvSpPr>
+              <p:cNvPr id="22" name="テキスト ボックス 21">
+                <a:extLst>
+                  <a:ext uri="{FF2B5EF4-FFF2-40B4-BE49-F238E27FC236}">
+                    <a16:creationId xmlns:a16="http://schemas.microsoft.com/office/drawing/2014/main" id="{7712D7F2-2353-03CB-F249-ECBCE4248A01}"/>
+                  </a:ext>
+                </a:extLst>
+              </p:cNvPr>
+              <p:cNvSpPr txBox="1"/>
+              <p:nvPr/>
+            </p:nvSpPr>
+            <p:spPr>
+              <a:xfrm>
+                <a:off x="3491129" y="2441089"/>
+                <a:ext cx="1024577" cy="461665"/>
+              </a:xfrm>
+              <a:prstGeom prst="rect">
+                <a:avLst/>
+              </a:prstGeom>
+              <a:noFill/>
+            </p:spPr>
+            <p:txBody>
+              <a:bodyPr wrap="square" rtlCol="0">
+                <a:spAutoFit/>
+              </a:bodyPr>
+              <a:lstStyle/>
+              <a:p>
+                <a:pPr algn="ctr"/>
+                <a:r>
+                  <a:rPr kumimoji="1" lang="ja-JP" altLang="en-US" sz="2400">
+                    <a:latin typeface="Hiragino Kaku Gothic StdN W8" panose="020B0800000000000000" pitchFamily="34" charset="-128"/>
+                    <a:ea typeface="Hiragino Kaku Gothic StdN W8" panose="020B0800000000000000" pitchFamily="34" charset="-128"/>
+                  </a:rPr>
+                  <a:t>日本</a:t>
+                </a:r>
+              </a:p>
+            </p:txBody>
+          </p:sp>
+          <p:sp>
+            <p:nvSpPr>
+              <p:cNvPr id="23" name="円/楕円 22">
+                <a:extLst>
+                  <a:ext uri="{FF2B5EF4-FFF2-40B4-BE49-F238E27FC236}">
+                    <a16:creationId xmlns:a16="http://schemas.microsoft.com/office/drawing/2014/main" id="{34B8D924-6630-E7A4-D42E-C2685DC7E19E}"/>
+                  </a:ext>
+                </a:extLst>
+              </p:cNvPr>
+              <p:cNvSpPr/>
+              <p:nvPr/>
+            </p:nvSpPr>
+            <p:spPr>
+              <a:xfrm>
+                <a:off x="1930271" y="273182"/>
+                <a:ext cx="4180231" cy="4180231"/>
+              </a:xfrm>
+              <a:prstGeom prst="ellipse">
+                <a:avLst/>
+              </a:prstGeom>
+              <a:noFill/>
+              <a:ln w="19050">
+                <a:solidFill>
+                  <a:schemeClr val="tx1"/>
+                </a:solidFill>
+              </a:ln>
+            </p:spPr>
+            <p:style>
+              <a:lnRef idx="2">
+                <a:schemeClr val="accent1">
+                  <a:shade val="15000"/>
+                </a:schemeClr>
+              </a:lnRef>
+              <a:fillRef idx="1">
+                <a:schemeClr val="accent1"/>
+              </a:fillRef>
+              <a:effectRef idx="0">
+                <a:schemeClr val="accent1"/>
+              </a:effectRef>
+              <a:fontRef idx="minor">
+                <a:schemeClr val="lt1"/>
+              </a:fontRef>
+            </p:style>
+            <p:txBody>
+              <a:bodyPr rtlCol="0" anchor="ctr"/>
+              <a:lstStyle/>
+              <a:p>
+                <a:pPr algn="ctr"/>
+                <a:endParaRPr kumimoji="1" lang="ja-JP" altLang="en-US"/>
+              </a:p>
+            </p:txBody>
+          </p:sp>
+        </p:grpSp>
+        <p:grpSp>
+          <p:nvGrpSpPr>
+            <p:cNvPr id="12" name="グループ化 11">
+              <a:extLst>
+                <a:ext uri="{FF2B5EF4-FFF2-40B4-BE49-F238E27FC236}">
+                  <a16:creationId xmlns:a16="http://schemas.microsoft.com/office/drawing/2014/main" id="{6413FA51-F5E2-45D5-7FC5-9410F8585A91}"/>
+                </a:ext>
+              </a:extLst>
+            </p:cNvPr>
+            <p:cNvGrpSpPr/>
+            <p:nvPr/>
+          </p:nvGrpSpPr>
+          <p:grpSpPr>
+            <a:xfrm>
+              <a:off x="5433827" y="1926096"/>
+              <a:ext cx="4180231" cy="4180231"/>
+              <a:chOff x="5450156" y="1722167"/>
+              <a:chExt cx="4180231" cy="4180231"/>
+            </a:xfrm>
+          </p:grpSpPr>
+          <p:sp>
+            <p:nvSpPr>
+              <p:cNvPr id="18" name="テキスト ボックス 17">
+                <a:extLst>
+                  <a:ext uri="{FF2B5EF4-FFF2-40B4-BE49-F238E27FC236}">
+                    <a16:creationId xmlns:a16="http://schemas.microsoft.com/office/drawing/2014/main" id="{64AD0313-0D9B-8EC7-E479-8DFF12994DA7}"/>
+                  </a:ext>
+                </a:extLst>
+              </p:cNvPr>
+              <p:cNvSpPr txBox="1"/>
+              <p:nvPr/>
+            </p:nvSpPr>
+            <p:spPr>
+              <a:xfrm>
+                <a:off x="7012666" y="3887531"/>
+                <a:ext cx="1024577" cy="461665"/>
+              </a:xfrm>
+              <a:prstGeom prst="rect">
+                <a:avLst/>
+              </a:prstGeom>
+              <a:noFill/>
+            </p:spPr>
+            <p:txBody>
+              <a:bodyPr wrap="square" rtlCol="0">
+                <a:spAutoFit/>
+              </a:bodyPr>
+              <a:lstStyle/>
+              <a:p>
+                <a:r>
+                  <a:rPr kumimoji="1" lang="ja-JP" altLang="en-US" sz="2400">
+                    <a:latin typeface="Hiragino Kaku Gothic StdN W8" panose="020B0800000000000000" pitchFamily="34" charset="-128"/>
+                    <a:ea typeface="Hiragino Kaku Gothic StdN W8" panose="020B0800000000000000" pitchFamily="34" charset="-128"/>
+                  </a:rPr>
+                  <a:t>米国</a:t>
+                </a:r>
+              </a:p>
+            </p:txBody>
+          </p:sp>
+          <p:sp>
+            <p:nvSpPr>
+              <p:cNvPr id="19" name="円/楕円 18">
+                <a:extLst>
+                  <a:ext uri="{FF2B5EF4-FFF2-40B4-BE49-F238E27FC236}">
+                    <a16:creationId xmlns:a16="http://schemas.microsoft.com/office/drawing/2014/main" id="{565CDA8B-1956-CAB7-5632-FD4D23D94485}"/>
+                  </a:ext>
+                </a:extLst>
+              </p:cNvPr>
+              <p:cNvSpPr/>
+              <p:nvPr/>
+            </p:nvSpPr>
+            <p:spPr>
+              <a:xfrm>
+                <a:off x="7467024" y="3716507"/>
+                <a:ext cx="186550" cy="186550"/>
+              </a:xfrm>
+              <a:prstGeom prst="ellipse">
+                <a:avLst/>
+              </a:prstGeom>
+              <a:solidFill>
+                <a:schemeClr val="tx1"/>
+              </a:solidFill>
+              <a:ln>
+                <a:noFill/>
+              </a:ln>
+            </p:spPr>
+            <p:style>
+              <a:lnRef idx="2">
+                <a:schemeClr val="accent1">
+                  <a:shade val="50000"/>
+                </a:schemeClr>
+              </a:lnRef>
+              <a:fillRef idx="1">
+                <a:schemeClr val="accent1"/>
+              </a:fillRef>
+              <a:effectRef idx="0">
+                <a:schemeClr val="accent1"/>
+              </a:effectRef>
+              <a:fontRef idx="minor">
+                <a:schemeClr val="lt1"/>
+              </a:fontRef>
+            </p:style>
+            <p:txBody>
+              <a:bodyPr rtlCol="0" anchor="ctr"/>
+              <a:lstStyle/>
+              <a:p>
+                <a:pPr algn="ctr"/>
+                <a:endParaRPr kumimoji="1" lang="ja-JP" altLang="en-US"/>
+              </a:p>
+            </p:txBody>
+          </p:sp>
+          <p:sp>
+            <p:nvSpPr>
+              <p:cNvPr id="20" name="円/楕円 19">
+                <a:extLst>
+                  <a:ext uri="{FF2B5EF4-FFF2-40B4-BE49-F238E27FC236}">
+                    <a16:creationId xmlns:a16="http://schemas.microsoft.com/office/drawing/2014/main" id="{B947CB25-D875-77C0-7C86-F0F87C6D6D4D}"/>
+                  </a:ext>
+                </a:extLst>
+              </p:cNvPr>
+              <p:cNvSpPr/>
+              <p:nvPr/>
+            </p:nvSpPr>
+            <p:spPr>
+              <a:xfrm>
+                <a:off x="5450156" y="1722167"/>
+                <a:ext cx="4180231" cy="4180231"/>
+              </a:xfrm>
+              <a:prstGeom prst="ellipse">
+                <a:avLst/>
+              </a:prstGeom>
+              <a:noFill/>
+              <a:ln w="19050">
+                <a:solidFill>
+                  <a:schemeClr val="tx1"/>
+                </a:solidFill>
+              </a:ln>
+            </p:spPr>
+            <p:style>
+              <a:lnRef idx="2">
+                <a:schemeClr val="accent1">
+                  <a:shade val="15000"/>
+                </a:schemeClr>
+              </a:lnRef>
+              <a:fillRef idx="1">
+                <a:schemeClr val="accent1"/>
+              </a:fillRef>
+              <a:effectRef idx="0">
+                <a:schemeClr val="accent1"/>
+              </a:effectRef>
+              <a:fontRef idx="minor">
+                <a:schemeClr val="lt1"/>
+              </a:fontRef>
+            </p:style>
+            <p:txBody>
+              <a:bodyPr rtlCol="0" anchor="ctr"/>
+              <a:lstStyle/>
+              <a:p>
+                <a:pPr algn="ctr"/>
+                <a:endParaRPr kumimoji="1" lang="ja-JP" altLang="en-US"/>
+              </a:p>
+            </p:txBody>
+          </p:sp>
+        </p:grpSp>
+        <p:grpSp>
+          <p:nvGrpSpPr>
+            <p:cNvPr id="13" name="グループ化 12">
+              <a:extLst>
+                <a:ext uri="{FF2B5EF4-FFF2-40B4-BE49-F238E27FC236}">
+                  <a16:creationId xmlns:a16="http://schemas.microsoft.com/office/drawing/2014/main" id="{7581442C-8033-310B-3808-75A04AA81A27}"/>
+                </a:ext>
+              </a:extLst>
+            </p:cNvPr>
+            <p:cNvGrpSpPr/>
+            <p:nvPr/>
+          </p:nvGrpSpPr>
+          <p:grpSpPr>
+            <a:xfrm>
+              <a:off x="6270771" y="1711020"/>
+              <a:ext cx="1024577" cy="555608"/>
+              <a:chOff x="6270771" y="1711020"/>
+              <a:chExt cx="1024577" cy="555608"/>
+            </a:xfrm>
+          </p:grpSpPr>
+          <p:sp>
+            <p:nvSpPr>
+              <p:cNvPr id="16" name="テキスト ボックス 15">
+                <a:extLst>
+                  <a:ext uri="{FF2B5EF4-FFF2-40B4-BE49-F238E27FC236}">
+                    <a16:creationId xmlns:a16="http://schemas.microsoft.com/office/drawing/2014/main" id="{71828FA5-061C-AF5C-9C35-16A412F921AC}"/>
+                  </a:ext>
+                </a:extLst>
+              </p:cNvPr>
+              <p:cNvSpPr txBox="1"/>
+              <p:nvPr/>
+            </p:nvSpPr>
+            <p:spPr>
+              <a:xfrm>
+                <a:off x="6270771" y="1711020"/>
+                <a:ext cx="1024577" cy="461665"/>
+              </a:xfrm>
+              <a:prstGeom prst="rect">
+                <a:avLst/>
+              </a:prstGeom>
+              <a:noFill/>
+            </p:spPr>
+            <p:txBody>
+              <a:bodyPr wrap="square" rtlCol="0">
+                <a:spAutoFit/>
+              </a:bodyPr>
+              <a:lstStyle/>
+              <a:p>
+                <a:r>
+                  <a:rPr kumimoji="1" lang="ja-JP" altLang="en-US" sz="2400">
+                    <a:latin typeface="Hiragino Kaku Gothic StdN W8" panose="020B0800000000000000" pitchFamily="34" charset="-128"/>
+                    <a:ea typeface="Hiragino Kaku Gothic StdN W8" panose="020B0800000000000000" pitchFamily="34" charset="-128"/>
+                  </a:rPr>
+                  <a:t>現状</a:t>
+                </a:r>
+              </a:p>
+            </p:txBody>
+          </p:sp>
+          <p:sp>
+            <p:nvSpPr>
+              <p:cNvPr id="17" name="円/楕円 16">
+                <a:extLst>
+                  <a:ext uri="{FF2B5EF4-FFF2-40B4-BE49-F238E27FC236}">
+                    <a16:creationId xmlns:a16="http://schemas.microsoft.com/office/drawing/2014/main" id="{527F636E-5B5D-DA3F-C107-8D5B20B7C845}"/>
+                  </a:ext>
+                </a:extLst>
+              </p:cNvPr>
+              <p:cNvSpPr/>
+              <p:nvPr/>
+            </p:nvSpPr>
+            <p:spPr>
+              <a:xfrm>
+                <a:off x="6419541" y="2080078"/>
+                <a:ext cx="186550" cy="186550"/>
+              </a:xfrm>
+              <a:prstGeom prst="ellipse">
+                <a:avLst/>
+              </a:prstGeom>
+              <a:solidFill>
+                <a:schemeClr val="tx1"/>
+              </a:solidFill>
+              <a:ln>
+                <a:noFill/>
+              </a:ln>
+            </p:spPr>
+            <p:style>
+              <a:lnRef idx="2">
+                <a:schemeClr val="accent1">
+                  <a:shade val="50000"/>
+                </a:schemeClr>
+              </a:lnRef>
+              <a:fillRef idx="1">
+                <a:schemeClr val="accent1"/>
+              </a:fillRef>
+              <a:effectRef idx="0">
+                <a:schemeClr val="accent1"/>
+              </a:effectRef>
+              <a:fontRef idx="minor">
+                <a:schemeClr val="lt1"/>
+              </a:fontRef>
+            </p:style>
+            <p:txBody>
+              <a:bodyPr rtlCol="0" anchor="ctr"/>
+              <a:lstStyle/>
+              <a:p>
+                <a:pPr algn="ctr"/>
+                <a:endParaRPr kumimoji="1" lang="ja-JP" altLang="en-US"/>
+              </a:p>
+            </p:txBody>
+          </p:sp>
+        </p:grpSp>
+      </p:grpSp>
+    </p:spTree>
+    <p:extLst>
+      <p:ext uri="{BB962C8B-B14F-4D97-AF65-F5344CB8AC3E}">
+        <p14:creationId xmlns:p14="http://schemas.microsoft.com/office/powerpoint/2010/main" val="2655794605"/>
+      </p:ext>
+    </p:extLst>
+  </p:cSld>
+  <p:clrMapOvr>
+    <a:masterClrMapping/>
+  </p:clrMapOvr>
+</p:sld>
+</file>
+
+<file path=ppt/slides/slide7.xml><?xml version="1.0" encoding="utf-8"?>
+<p:sld xmlns:a="http://schemas.openxmlformats.org/drawingml/2006/main" xmlns:r="http://schemas.openxmlformats.org/officeDocument/2006/relationships" xmlns:p="http://schemas.openxmlformats.org/presentationml/2006/main">
+  <p:cSld>
+    <p:spTree>
+      <p:nvGrpSpPr>
+        <p:cNvPr id="1" name=""/>
+        <p:cNvGrpSpPr/>
+        <p:nvPr/>
+      </p:nvGrpSpPr>
+      <p:grpSpPr>
+        <a:xfrm>
+          <a:off x="0" y="0"/>
+          <a:ext cx="0" cy="0"/>
+          <a:chOff x="0" y="0"/>
+          <a:chExt cx="0" cy="0"/>
+        </a:xfrm>
+      </p:grpSpPr>
+      <p:grpSp>
+        <p:nvGrpSpPr>
+          <p:cNvPr id="86" name="グループ化 85">
+            <a:extLst>
+              <a:ext uri="{FF2B5EF4-FFF2-40B4-BE49-F238E27FC236}">
+                <a16:creationId xmlns:a16="http://schemas.microsoft.com/office/drawing/2014/main" id="{F057E61F-C13B-435C-BE32-D177B1444EEF}"/>
+              </a:ext>
+            </a:extLst>
+          </p:cNvPr>
+          <p:cNvGrpSpPr/>
+          <p:nvPr/>
+        </p:nvGrpSpPr>
+        <p:grpSpPr>
+          <a:xfrm>
+            <a:off x="766152" y="390292"/>
+            <a:ext cx="9994775" cy="6304768"/>
+            <a:chOff x="766152" y="390292"/>
+            <a:chExt cx="9994775" cy="6304768"/>
+          </a:xfrm>
+        </p:grpSpPr>
+        <p:cxnSp>
+          <p:nvCxnSpPr>
+            <p:cNvPr id="5" name="直線矢印コネクタ 4">
+              <a:extLst>
+                <a:ext uri="{FF2B5EF4-FFF2-40B4-BE49-F238E27FC236}">
+                  <a16:creationId xmlns:a16="http://schemas.microsoft.com/office/drawing/2014/main" id="{EB33F547-F7D8-7A97-03FB-4FAED7CA71DD}"/>
+                </a:ext>
+              </a:extLst>
+            </p:cNvPr>
+            <p:cNvCxnSpPr>
+              <a:cxnSpLocks/>
+            </p:cNvCxnSpPr>
+            <p:nvPr/>
+          </p:nvCxnSpPr>
+          <p:spPr>
+            <a:xfrm>
+              <a:off x="1320150" y="6216979"/>
+              <a:ext cx="9440777" cy="0"/>
+            </a:xfrm>
+            <a:prstGeom prst="straightConnector1">
+              <a:avLst/>
+            </a:prstGeom>
+            <a:ln w="28575">
+              <a:solidFill>
+                <a:schemeClr val="tx1"/>
+              </a:solidFill>
+              <a:tailEnd type="triangle"/>
+            </a:ln>
+          </p:spPr>
+          <p:style>
+            <a:lnRef idx="1">
+              <a:schemeClr val="accent1"/>
+            </a:lnRef>
+            <a:fillRef idx="0">
+              <a:schemeClr val="accent1"/>
+            </a:fillRef>
+            <a:effectRef idx="0">
+              <a:schemeClr val="accent1"/>
+            </a:effectRef>
+            <a:fontRef idx="minor">
+              <a:schemeClr val="tx1"/>
+            </a:fontRef>
+          </p:style>
+        </p:cxnSp>
+        <p:cxnSp>
+          <p:nvCxnSpPr>
+            <p:cNvPr id="6" name="直線矢印コネクタ 5">
+              <a:extLst>
+                <a:ext uri="{FF2B5EF4-FFF2-40B4-BE49-F238E27FC236}">
+                  <a16:creationId xmlns:a16="http://schemas.microsoft.com/office/drawing/2014/main" id="{FD2BB151-BE11-1FD6-A469-149633D783E5}"/>
+                </a:ext>
+              </a:extLst>
+            </p:cNvPr>
+            <p:cNvCxnSpPr>
+              <a:cxnSpLocks/>
+            </p:cNvCxnSpPr>
+            <p:nvPr/>
+          </p:nvCxnSpPr>
+          <p:spPr>
+            <a:xfrm flipV="1">
+              <a:off x="1320150" y="390293"/>
+              <a:ext cx="0" cy="5826686"/>
+            </a:xfrm>
+            <a:prstGeom prst="straightConnector1">
+              <a:avLst/>
+            </a:prstGeom>
+            <a:ln w="28575">
+              <a:solidFill>
+                <a:schemeClr val="tx1"/>
+              </a:solidFill>
+              <a:tailEnd type="triangle"/>
+            </a:ln>
+          </p:spPr>
+          <p:style>
+            <a:lnRef idx="1">
+              <a:schemeClr val="accent1"/>
+            </a:lnRef>
+            <a:fillRef idx="0">
+              <a:schemeClr val="accent1"/>
+            </a:fillRef>
+            <a:effectRef idx="0">
+              <a:schemeClr val="accent1"/>
+            </a:effectRef>
+            <a:fontRef idx="minor">
+              <a:schemeClr val="tx1"/>
+            </a:fontRef>
+          </p:style>
+        </p:cxnSp>
+        <p:sp>
+          <p:nvSpPr>
+            <p:cNvPr id="7" name="テキスト ボックス 6">
+              <a:extLst>
+                <a:ext uri="{FF2B5EF4-FFF2-40B4-BE49-F238E27FC236}">
+                  <a16:creationId xmlns:a16="http://schemas.microsoft.com/office/drawing/2014/main" id="{BEB57F3C-0323-CCA4-7F64-727AD8DB7DF5}"/>
+                </a:ext>
+              </a:extLst>
+            </p:cNvPr>
+            <p:cNvSpPr txBox="1"/>
+            <p:nvPr/>
+          </p:nvSpPr>
+          <p:spPr>
+            <a:xfrm>
+              <a:off x="9248061" y="6233395"/>
+              <a:ext cx="1512866" cy="461665"/>
+            </a:xfrm>
+            <a:prstGeom prst="rect">
+              <a:avLst/>
+            </a:prstGeom>
+            <a:noFill/>
+          </p:spPr>
+          <p:txBody>
+            <a:bodyPr wrap="square" rtlCol="0">
+              <a:spAutoFit/>
+            </a:bodyPr>
+            <a:lstStyle/>
+            <a:p>
+              <a:pPr algn="ctr"/>
+              <a:r>
+                <a:rPr kumimoji="1" lang="ja-JP" altLang="en-US" sz="2400">
+                  <a:latin typeface="Hiragino Kaku Gothic StdN W8" panose="020B0800000000000000" pitchFamily="34" charset="-128"/>
+                  <a:ea typeface="Hiragino Kaku Gothic StdN W8" panose="020B0800000000000000" pitchFamily="34" charset="-128"/>
+                </a:rPr>
+                <a:t>車関税率</a:t>
+              </a:r>
+            </a:p>
+          </p:txBody>
+        </p:sp>
+        <p:sp>
+          <p:nvSpPr>
+            <p:cNvPr id="8" name="テキスト ボックス 7">
+              <a:extLst>
+                <a:ext uri="{FF2B5EF4-FFF2-40B4-BE49-F238E27FC236}">
+                  <a16:creationId xmlns:a16="http://schemas.microsoft.com/office/drawing/2014/main" id="{3E19D6D4-DC2F-6F64-086A-3235F44D82DE}"/>
+                </a:ext>
+              </a:extLst>
+            </p:cNvPr>
+            <p:cNvSpPr txBox="1"/>
+            <p:nvPr/>
+          </p:nvSpPr>
+          <p:spPr>
+            <a:xfrm>
+              <a:off x="766152" y="390292"/>
+              <a:ext cx="553998" cy="1323439"/>
+            </a:xfrm>
+            <a:prstGeom prst="rect">
+              <a:avLst/>
+            </a:prstGeom>
+            <a:noFill/>
+          </p:spPr>
+          <p:txBody>
+            <a:bodyPr vert="eaVert" wrap="none" rtlCol="0">
+              <a:spAutoFit/>
+            </a:bodyPr>
+            <a:lstStyle/>
+            <a:p>
+              <a:r>
+                <a:rPr kumimoji="1" lang="ja-JP" altLang="en-US" sz="2400">
+                  <a:latin typeface="Hiragino Kaku Gothic StdN W8" panose="020B0800000000000000" pitchFamily="34" charset="-128"/>
+                  <a:ea typeface="Hiragino Kaku Gothic StdN W8" panose="020B0800000000000000" pitchFamily="34" charset="-128"/>
+                </a:rPr>
+                <a:t>肉関税率</a:t>
+              </a:r>
+            </a:p>
+          </p:txBody>
+        </p:sp>
+        <p:cxnSp>
+          <p:nvCxnSpPr>
+            <p:cNvPr id="16" name="直線矢印コネクタ 15">
+              <a:extLst>
+                <a:ext uri="{FF2B5EF4-FFF2-40B4-BE49-F238E27FC236}">
+                  <a16:creationId xmlns:a16="http://schemas.microsoft.com/office/drawing/2014/main" id="{FF4AA89A-8567-F5F1-E3C2-3E6CBF59A7C7}"/>
+                </a:ext>
+              </a:extLst>
+            </p:cNvPr>
+            <p:cNvCxnSpPr>
+              <a:cxnSpLocks/>
+              <a:stCxn id="18" idx="0"/>
+              <a:endCxn id="69" idx="3"/>
+            </p:cNvCxnSpPr>
+            <p:nvPr/>
+          </p:nvCxnSpPr>
+          <p:spPr>
+            <a:xfrm flipV="1">
+              <a:off x="3821015" y="5494146"/>
+              <a:ext cx="2224993" cy="94562"/>
+            </a:xfrm>
+            <a:prstGeom prst="straightConnector1">
+              <a:avLst/>
+            </a:prstGeom>
+            <a:ln w="57150">
+              <a:solidFill>
+                <a:schemeClr val="tx1"/>
+              </a:solidFill>
+              <a:tailEnd type="triangle"/>
+            </a:ln>
+          </p:spPr>
+          <p:style>
+            <a:lnRef idx="1">
+              <a:schemeClr val="accent1"/>
+            </a:lnRef>
+            <a:fillRef idx="0">
+              <a:schemeClr val="accent1"/>
+            </a:fillRef>
+            <a:effectRef idx="0">
+              <a:schemeClr val="accent1"/>
+            </a:effectRef>
+            <a:fontRef idx="minor">
+              <a:schemeClr val="tx1"/>
+            </a:fontRef>
+          </p:style>
+        </p:cxnSp>
+        <p:cxnSp>
+          <p:nvCxnSpPr>
+            <p:cNvPr id="17" name="直線矢印コネクタ 16">
+              <a:extLst>
+                <a:ext uri="{FF2B5EF4-FFF2-40B4-BE49-F238E27FC236}">
+                  <a16:creationId xmlns:a16="http://schemas.microsoft.com/office/drawing/2014/main" id="{CA4D3983-B276-B546-7750-72A6A245F87C}"/>
+                </a:ext>
+              </a:extLst>
+            </p:cNvPr>
+            <p:cNvCxnSpPr>
+              <a:cxnSpLocks/>
+              <a:stCxn id="18" idx="0"/>
+              <a:endCxn id="56" idx="4"/>
+            </p:cNvCxnSpPr>
+            <p:nvPr/>
+          </p:nvCxnSpPr>
+          <p:spPr>
+            <a:xfrm flipV="1">
+              <a:off x="3821015" y="4570523"/>
+              <a:ext cx="623580" cy="1018185"/>
+            </a:xfrm>
+            <a:prstGeom prst="straightConnector1">
+              <a:avLst/>
+            </a:prstGeom>
+            <a:ln w="57150">
+              <a:solidFill>
+                <a:schemeClr val="tx1"/>
+              </a:solidFill>
+              <a:tailEnd type="triangle"/>
+            </a:ln>
+          </p:spPr>
+          <p:style>
+            <a:lnRef idx="1">
+              <a:schemeClr val="accent1"/>
+            </a:lnRef>
+            <a:fillRef idx="0">
+              <a:schemeClr val="accent1"/>
+            </a:fillRef>
+            <a:effectRef idx="0">
+              <a:schemeClr val="accent1"/>
+            </a:effectRef>
+            <a:fontRef idx="minor">
+              <a:schemeClr val="tx1"/>
+            </a:fontRef>
+          </p:style>
+        </p:cxnSp>
+        <p:cxnSp>
+          <p:nvCxnSpPr>
+            <p:cNvPr id="39" name="直線矢印コネクタ 38">
+              <a:extLst>
+                <a:ext uri="{FF2B5EF4-FFF2-40B4-BE49-F238E27FC236}">
+                  <a16:creationId xmlns:a16="http://schemas.microsoft.com/office/drawing/2014/main" id="{451AFBC7-7AC4-ECA0-2AF2-E5F9B8AE017F}"/>
+                </a:ext>
+              </a:extLst>
+            </p:cNvPr>
+            <p:cNvCxnSpPr>
+              <a:cxnSpLocks/>
+              <a:stCxn id="36" idx="1"/>
+              <a:endCxn id="10" idx="7"/>
+            </p:cNvCxnSpPr>
+            <p:nvPr/>
+          </p:nvCxnSpPr>
+          <p:spPr>
+            <a:xfrm flipH="1">
+              <a:off x="4528925" y="817807"/>
+              <a:ext cx="1390612" cy="1573786"/>
+            </a:xfrm>
+            <a:prstGeom prst="straightConnector1">
+              <a:avLst/>
+            </a:prstGeom>
+            <a:ln w="57150">
+              <a:solidFill>
+                <a:schemeClr val="tx1"/>
+              </a:solidFill>
+              <a:tailEnd type="triangle"/>
+            </a:ln>
+          </p:spPr>
+          <p:style>
+            <a:lnRef idx="1">
+              <a:schemeClr val="accent1"/>
+            </a:lnRef>
+            <a:fillRef idx="0">
+              <a:schemeClr val="accent1"/>
+            </a:fillRef>
+            <a:effectRef idx="0">
+              <a:schemeClr val="accent1"/>
+            </a:effectRef>
+            <a:fontRef idx="minor">
+              <a:schemeClr val="tx1"/>
+            </a:fontRef>
+          </p:style>
+        </p:cxnSp>
+        <p:cxnSp>
+          <p:nvCxnSpPr>
+            <p:cNvPr id="45" name="直線矢印コネクタ 44">
+              <a:extLst>
+                <a:ext uri="{FF2B5EF4-FFF2-40B4-BE49-F238E27FC236}">
+                  <a16:creationId xmlns:a16="http://schemas.microsoft.com/office/drawing/2014/main" id="{01C2DD67-94EA-CF0B-E8C8-8CE605839F57}"/>
+                </a:ext>
+              </a:extLst>
+            </p:cNvPr>
+            <p:cNvCxnSpPr>
+              <a:cxnSpLocks/>
+              <a:stCxn id="36" idx="2"/>
+              <a:endCxn id="54" idx="0"/>
+            </p:cNvCxnSpPr>
+            <p:nvPr/>
+          </p:nvCxnSpPr>
+          <p:spPr>
+            <a:xfrm flipH="1">
+              <a:off x="7543970" y="1233305"/>
+              <a:ext cx="796262" cy="2687131"/>
+            </a:xfrm>
+            <a:prstGeom prst="straightConnector1">
+              <a:avLst/>
+            </a:prstGeom>
+            <a:ln w="57150">
+              <a:solidFill>
+                <a:schemeClr val="tx1"/>
+              </a:solidFill>
+              <a:tailEnd type="triangle"/>
+            </a:ln>
+          </p:spPr>
+          <p:style>
+            <a:lnRef idx="1">
+              <a:schemeClr val="accent1"/>
+            </a:lnRef>
+            <a:fillRef idx="0">
+              <a:schemeClr val="accent1"/>
+            </a:fillRef>
+            <a:effectRef idx="0">
+              <a:schemeClr val="accent1"/>
+            </a:effectRef>
+            <a:fontRef idx="minor">
+              <a:schemeClr val="tx1"/>
+            </a:fontRef>
+          </p:style>
+        </p:cxnSp>
+        <p:grpSp>
+          <p:nvGrpSpPr>
+            <p:cNvPr id="61" name="グループ化 60">
+              <a:extLst>
+                <a:ext uri="{FF2B5EF4-FFF2-40B4-BE49-F238E27FC236}">
+                  <a16:creationId xmlns:a16="http://schemas.microsoft.com/office/drawing/2014/main" id="{5AFAEE14-22A3-B364-BD5A-FAAFFB4371CD}"/>
+                </a:ext>
+              </a:extLst>
+            </p:cNvPr>
+            <p:cNvGrpSpPr/>
+            <p:nvPr/>
+          </p:nvGrpSpPr>
+          <p:grpSpPr>
+            <a:xfrm>
+              <a:off x="2354479" y="390292"/>
+              <a:ext cx="4180231" cy="4180231"/>
+              <a:chOff x="1930271" y="273182"/>
+              <a:chExt cx="4180231" cy="4180231"/>
+            </a:xfrm>
+          </p:grpSpPr>
+          <p:sp>
+            <p:nvSpPr>
+              <p:cNvPr id="10" name="円/楕円 9">
+                <a:extLst>
+                  <a:ext uri="{FF2B5EF4-FFF2-40B4-BE49-F238E27FC236}">
+                    <a16:creationId xmlns:a16="http://schemas.microsoft.com/office/drawing/2014/main" id="{2C54090F-5BDF-8E1A-9525-728FC811FC67}"/>
+                  </a:ext>
+                </a:extLst>
+              </p:cNvPr>
+              <p:cNvSpPr/>
+              <p:nvPr/>
+            </p:nvSpPr>
+            <p:spPr>
+              <a:xfrm>
+                <a:off x="3945487" y="2247163"/>
+                <a:ext cx="186550" cy="186550"/>
+              </a:xfrm>
+              <a:prstGeom prst="ellipse">
+                <a:avLst/>
+              </a:prstGeom>
+              <a:solidFill>
+                <a:schemeClr val="tx1"/>
+              </a:solidFill>
+              <a:ln>
+                <a:noFill/>
+              </a:ln>
+            </p:spPr>
+            <p:style>
+              <a:lnRef idx="2">
+                <a:schemeClr val="accent1">
+                  <a:shade val="50000"/>
+                </a:schemeClr>
+              </a:lnRef>
+              <a:fillRef idx="1">
+                <a:schemeClr val="accent1"/>
+              </a:fillRef>
+              <a:effectRef idx="0">
+                <a:schemeClr val="accent1"/>
+              </a:effectRef>
+              <a:fontRef idx="minor">
+                <a:schemeClr val="lt1"/>
+              </a:fontRef>
+            </p:style>
+            <p:txBody>
+              <a:bodyPr rtlCol="0" anchor="ctr"/>
+              <a:lstStyle/>
+              <a:p>
+                <a:pPr algn="ctr"/>
+                <a:endParaRPr kumimoji="1" lang="ja-JP" altLang="en-US"/>
+              </a:p>
+            </p:txBody>
+          </p:sp>
+          <p:sp>
+            <p:nvSpPr>
+              <p:cNvPr id="12" name="テキスト ボックス 11">
+                <a:extLst>
+                  <a:ext uri="{FF2B5EF4-FFF2-40B4-BE49-F238E27FC236}">
+                    <a16:creationId xmlns:a16="http://schemas.microsoft.com/office/drawing/2014/main" id="{6306C529-4AB1-A3A4-9578-23E6532D7165}"/>
+                  </a:ext>
+                </a:extLst>
+              </p:cNvPr>
+              <p:cNvSpPr txBox="1"/>
+              <p:nvPr/>
+            </p:nvSpPr>
+            <p:spPr>
+              <a:xfrm>
+                <a:off x="3491129" y="2441089"/>
+                <a:ext cx="1024577" cy="461665"/>
+              </a:xfrm>
+              <a:prstGeom prst="rect">
+                <a:avLst/>
+              </a:prstGeom>
+              <a:noFill/>
+            </p:spPr>
+            <p:txBody>
+              <a:bodyPr wrap="square" rtlCol="0">
+                <a:spAutoFit/>
+              </a:bodyPr>
+              <a:lstStyle/>
+              <a:p>
+                <a:pPr algn="ctr"/>
+                <a:r>
+                  <a:rPr kumimoji="1" lang="ja-JP" altLang="en-US" sz="2400">
+                    <a:latin typeface="Hiragino Kaku Gothic StdN W8" panose="020B0800000000000000" pitchFamily="34" charset="-128"/>
+                    <a:ea typeface="Hiragino Kaku Gothic StdN W8" panose="020B0800000000000000" pitchFamily="34" charset="-128"/>
+                  </a:rPr>
+                  <a:t>日本</a:t>
+                </a:r>
+              </a:p>
+            </p:txBody>
+          </p:sp>
+          <p:sp>
+            <p:nvSpPr>
+              <p:cNvPr id="56" name="円/楕円 55">
+                <a:extLst>
+                  <a:ext uri="{FF2B5EF4-FFF2-40B4-BE49-F238E27FC236}">
+                    <a16:creationId xmlns:a16="http://schemas.microsoft.com/office/drawing/2014/main" id="{9CF91C15-1008-EE4A-1A57-2081DB87EBBF}"/>
+                  </a:ext>
+                </a:extLst>
+              </p:cNvPr>
+              <p:cNvSpPr/>
+              <p:nvPr/>
+            </p:nvSpPr>
+            <p:spPr>
+              <a:xfrm>
+                <a:off x="1930271" y="273182"/>
+                <a:ext cx="4180231" cy="4180231"/>
+              </a:xfrm>
+              <a:prstGeom prst="ellipse">
+                <a:avLst/>
+              </a:prstGeom>
+              <a:noFill/>
+              <a:ln w="19050">
+                <a:solidFill>
+                  <a:schemeClr val="tx1"/>
+                </a:solidFill>
+              </a:ln>
+            </p:spPr>
+            <p:style>
+              <a:lnRef idx="2">
+                <a:schemeClr val="accent1">
+                  <a:shade val="15000"/>
+                </a:schemeClr>
+              </a:lnRef>
+              <a:fillRef idx="1">
+                <a:schemeClr val="accent1"/>
+              </a:fillRef>
+              <a:effectRef idx="0">
+                <a:schemeClr val="accent1"/>
+              </a:effectRef>
+              <a:fontRef idx="minor">
+                <a:schemeClr val="lt1"/>
+              </a:fontRef>
+            </p:style>
+            <p:txBody>
+              <a:bodyPr rtlCol="0" anchor="ctr"/>
+              <a:lstStyle/>
+              <a:p>
+                <a:pPr algn="ctr"/>
+                <a:endParaRPr kumimoji="1" lang="ja-JP" altLang="en-US"/>
+              </a:p>
+            </p:txBody>
+          </p:sp>
+        </p:grpSp>
+        <p:grpSp>
+          <p:nvGrpSpPr>
+            <p:cNvPr id="70" name="グループ化 69">
+              <a:extLst>
+                <a:ext uri="{FF2B5EF4-FFF2-40B4-BE49-F238E27FC236}">
+                  <a16:creationId xmlns:a16="http://schemas.microsoft.com/office/drawing/2014/main" id="{D1A10B28-3450-9483-7F89-685300AF3A07}"/>
+                </a:ext>
+              </a:extLst>
+            </p:cNvPr>
+            <p:cNvGrpSpPr/>
+            <p:nvPr/>
+          </p:nvGrpSpPr>
+          <p:grpSpPr>
+            <a:xfrm>
+              <a:off x="5433827" y="1926096"/>
+              <a:ext cx="4180231" cy="4180231"/>
+              <a:chOff x="5450156" y="1722167"/>
+              <a:chExt cx="4180231" cy="4180231"/>
+            </a:xfrm>
+          </p:grpSpPr>
+          <p:sp>
+            <p:nvSpPr>
+              <p:cNvPr id="11" name="テキスト ボックス 10">
+                <a:extLst>
+                  <a:ext uri="{FF2B5EF4-FFF2-40B4-BE49-F238E27FC236}">
+                    <a16:creationId xmlns:a16="http://schemas.microsoft.com/office/drawing/2014/main" id="{1C37FCF3-51F2-CB0F-D820-E7CB21A8EAD9}"/>
+                  </a:ext>
+                </a:extLst>
+              </p:cNvPr>
+              <p:cNvSpPr txBox="1"/>
+              <p:nvPr/>
+            </p:nvSpPr>
+            <p:spPr>
+              <a:xfrm>
+                <a:off x="7012666" y="3887531"/>
+                <a:ext cx="1024577" cy="461665"/>
+              </a:xfrm>
+              <a:prstGeom prst="rect">
+                <a:avLst/>
+              </a:prstGeom>
+              <a:noFill/>
+            </p:spPr>
+            <p:txBody>
+              <a:bodyPr wrap="square" rtlCol="0">
+                <a:spAutoFit/>
+              </a:bodyPr>
+              <a:lstStyle/>
+              <a:p>
+                <a:r>
+                  <a:rPr kumimoji="1" lang="ja-JP" altLang="en-US" sz="2400">
+                    <a:latin typeface="Hiragino Kaku Gothic StdN W8" panose="020B0800000000000000" pitchFamily="34" charset="-128"/>
+                    <a:ea typeface="Hiragino Kaku Gothic StdN W8" panose="020B0800000000000000" pitchFamily="34" charset="-128"/>
+                  </a:rPr>
+                  <a:t>米国</a:t>
+                </a:r>
+              </a:p>
+            </p:txBody>
+          </p:sp>
+          <p:sp>
+            <p:nvSpPr>
+              <p:cNvPr id="54" name="円/楕円 53">
+                <a:extLst>
+                  <a:ext uri="{FF2B5EF4-FFF2-40B4-BE49-F238E27FC236}">
+                    <a16:creationId xmlns:a16="http://schemas.microsoft.com/office/drawing/2014/main" id="{EC3FF6CC-06A8-D43E-95AF-BD94DEB76569}"/>
+                  </a:ext>
+                </a:extLst>
+              </p:cNvPr>
+              <p:cNvSpPr/>
+              <p:nvPr/>
+            </p:nvSpPr>
+            <p:spPr>
+              <a:xfrm>
+                <a:off x="7467024" y="3716507"/>
+                <a:ext cx="186550" cy="186550"/>
+              </a:xfrm>
+              <a:prstGeom prst="ellipse">
+                <a:avLst/>
+              </a:prstGeom>
+              <a:solidFill>
+                <a:schemeClr val="tx1"/>
+              </a:solidFill>
+              <a:ln>
+                <a:noFill/>
+              </a:ln>
+            </p:spPr>
+            <p:style>
+              <a:lnRef idx="2">
+                <a:schemeClr val="accent1">
+                  <a:shade val="50000"/>
+                </a:schemeClr>
+              </a:lnRef>
+              <a:fillRef idx="1">
+                <a:schemeClr val="accent1"/>
+              </a:fillRef>
+              <a:effectRef idx="0">
+                <a:schemeClr val="accent1"/>
+              </a:effectRef>
+              <a:fontRef idx="minor">
+                <a:schemeClr val="lt1"/>
+              </a:fontRef>
+            </p:style>
+            <p:txBody>
+              <a:bodyPr rtlCol="0" anchor="ctr"/>
+              <a:lstStyle/>
+              <a:p>
+                <a:pPr algn="ctr"/>
+                <a:endParaRPr kumimoji="1" lang="ja-JP" altLang="en-US"/>
+              </a:p>
+            </p:txBody>
+          </p:sp>
+          <p:sp>
+            <p:nvSpPr>
+              <p:cNvPr id="69" name="円/楕円 68">
+                <a:extLst>
+                  <a:ext uri="{FF2B5EF4-FFF2-40B4-BE49-F238E27FC236}">
+                    <a16:creationId xmlns:a16="http://schemas.microsoft.com/office/drawing/2014/main" id="{098F2BBD-4268-2151-1436-68F4912F76F0}"/>
+                  </a:ext>
+                </a:extLst>
+              </p:cNvPr>
+              <p:cNvSpPr/>
+              <p:nvPr/>
+            </p:nvSpPr>
+            <p:spPr>
+              <a:xfrm>
+                <a:off x="5450156" y="1722167"/>
+                <a:ext cx="4180231" cy="4180231"/>
+              </a:xfrm>
+              <a:prstGeom prst="ellipse">
+                <a:avLst/>
+              </a:prstGeom>
+              <a:noFill/>
+              <a:ln w="19050">
+                <a:solidFill>
+                  <a:schemeClr val="tx1"/>
+                </a:solidFill>
+              </a:ln>
+            </p:spPr>
+            <p:style>
+              <a:lnRef idx="2">
+                <a:schemeClr val="accent1">
+                  <a:shade val="15000"/>
+                </a:schemeClr>
+              </a:lnRef>
+              <a:fillRef idx="1">
+                <a:schemeClr val="accent1"/>
+              </a:fillRef>
+              <a:effectRef idx="0">
+                <a:schemeClr val="accent1"/>
+              </a:effectRef>
+              <a:fontRef idx="minor">
+                <a:schemeClr val="lt1"/>
+              </a:fontRef>
+            </p:style>
+            <p:txBody>
+              <a:bodyPr rtlCol="0" anchor="ctr"/>
+              <a:lstStyle/>
+              <a:p>
+                <a:pPr algn="ctr"/>
+                <a:endParaRPr kumimoji="1" lang="ja-JP" altLang="en-US"/>
+              </a:p>
+            </p:txBody>
+          </p:sp>
+        </p:grpSp>
+        <p:grpSp>
+          <p:nvGrpSpPr>
+            <p:cNvPr id="85" name="グループ化 84">
+              <a:extLst>
+                <a:ext uri="{FF2B5EF4-FFF2-40B4-BE49-F238E27FC236}">
+                  <a16:creationId xmlns:a16="http://schemas.microsoft.com/office/drawing/2014/main" id="{AA92FCEE-3E88-E65B-FFEB-F64CAC1511AA}"/>
+                </a:ext>
+              </a:extLst>
+            </p:cNvPr>
+            <p:cNvGrpSpPr/>
+            <p:nvPr/>
+          </p:nvGrpSpPr>
+          <p:grpSpPr>
+            <a:xfrm>
+              <a:off x="6270771" y="1711020"/>
+              <a:ext cx="1024577" cy="555608"/>
+              <a:chOff x="6270771" y="1711020"/>
+              <a:chExt cx="1024577" cy="555608"/>
+            </a:xfrm>
+          </p:grpSpPr>
+          <p:sp>
+            <p:nvSpPr>
+              <p:cNvPr id="14" name="テキスト ボックス 13">
+                <a:extLst>
+                  <a:ext uri="{FF2B5EF4-FFF2-40B4-BE49-F238E27FC236}">
+                    <a16:creationId xmlns:a16="http://schemas.microsoft.com/office/drawing/2014/main" id="{6D192728-DE81-0704-0633-94CC9340E4C1}"/>
+                  </a:ext>
+                </a:extLst>
+              </p:cNvPr>
+              <p:cNvSpPr txBox="1"/>
+              <p:nvPr/>
+            </p:nvSpPr>
+            <p:spPr>
+              <a:xfrm>
+                <a:off x="6270771" y="1711020"/>
+                <a:ext cx="1024577" cy="461665"/>
+              </a:xfrm>
+              <a:prstGeom prst="rect">
+                <a:avLst/>
+              </a:prstGeom>
+              <a:noFill/>
+            </p:spPr>
+            <p:txBody>
+              <a:bodyPr wrap="square" rtlCol="0">
+                <a:spAutoFit/>
+              </a:bodyPr>
+              <a:lstStyle/>
+              <a:p>
+                <a:r>
+                  <a:rPr kumimoji="1" lang="ja-JP" altLang="en-US" sz="2400">
+                    <a:latin typeface="Hiragino Kaku Gothic StdN W8" panose="020B0800000000000000" pitchFamily="34" charset="-128"/>
+                    <a:ea typeface="Hiragino Kaku Gothic StdN W8" panose="020B0800000000000000" pitchFamily="34" charset="-128"/>
+                  </a:rPr>
+                  <a:t>現状</a:t>
+                </a:r>
+              </a:p>
+            </p:txBody>
+          </p:sp>
+          <p:sp>
+            <p:nvSpPr>
+              <p:cNvPr id="83" name="円/楕円 82">
+                <a:extLst>
+                  <a:ext uri="{FF2B5EF4-FFF2-40B4-BE49-F238E27FC236}">
+                    <a16:creationId xmlns:a16="http://schemas.microsoft.com/office/drawing/2014/main" id="{E5931750-6C45-5E24-F2F5-628DB08F9727}"/>
+                  </a:ext>
+                </a:extLst>
+              </p:cNvPr>
+              <p:cNvSpPr/>
+              <p:nvPr/>
+            </p:nvSpPr>
+            <p:spPr>
+              <a:xfrm>
+                <a:off x="6419541" y="2080078"/>
+                <a:ext cx="186550" cy="186550"/>
+              </a:xfrm>
+              <a:prstGeom prst="ellipse">
+                <a:avLst/>
+              </a:prstGeom>
+              <a:solidFill>
+                <a:schemeClr val="tx1"/>
+              </a:solidFill>
+              <a:ln>
+                <a:noFill/>
+              </a:ln>
+            </p:spPr>
+            <p:style>
+              <a:lnRef idx="2">
+                <a:schemeClr val="accent1">
+                  <a:shade val="50000"/>
+                </a:schemeClr>
+              </a:lnRef>
+              <a:fillRef idx="1">
+                <a:schemeClr val="accent1"/>
+              </a:fillRef>
+              <a:effectRef idx="0">
+                <a:schemeClr val="accent1"/>
+              </a:effectRef>
+              <a:fontRef idx="minor">
+                <a:schemeClr val="lt1"/>
+              </a:fontRef>
+            </p:style>
+            <p:txBody>
+              <a:bodyPr rtlCol="0" anchor="ctr"/>
+              <a:lstStyle/>
+              <a:p>
+                <a:pPr algn="ctr"/>
+                <a:endParaRPr kumimoji="1" lang="ja-JP" altLang="en-US"/>
+              </a:p>
+            </p:txBody>
+          </p:sp>
+        </p:grpSp>
+        <p:sp>
+          <p:nvSpPr>
+            <p:cNvPr id="36" name="テキスト ボックス 35">
+              <a:extLst>
+                <a:ext uri="{FF2B5EF4-FFF2-40B4-BE49-F238E27FC236}">
+                  <a16:creationId xmlns:a16="http://schemas.microsoft.com/office/drawing/2014/main" id="{D8E5F7C8-44BC-6DCA-C1C4-BEF58A338DDE}"/>
+                </a:ext>
+              </a:extLst>
+            </p:cNvPr>
+            <p:cNvSpPr txBox="1"/>
+            <p:nvPr/>
+          </p:nvSpPr>
+          <p:spPr>
+            <a:xfrm>
+              <a:off x="5919537" y="402308"/>
+              <a:ext cx="4841390" cy="830997"/>
+            </a:xfrm>
+            <a:prstGeom prst="rect">
+              <a:avLst/>
+            </a:prstGeom>
+            <a:solidFill>
+              <a:schemeClr val="bg1"/>
+            </a:solidFill>
+            <a:ln>
+              <a:solidFill>
+                <a:schemeClr val="tx1"/>
+              </a:solidFill>
+            </a:ln>
+          </p:spPr>
+          <p:txBody>
+            <a:bodyPr wrap="square" rtlCol="0">
+              <a:spAutoFit/>
+            </a:bodyPr>
+            <a:lstStyle/>
+            <a:p>
+              <a:r>
+                <a:rPr kumimoji="1" lang="ja-JP" altLang="en-US" sz="2400" b="1">
+                  <a:latin typeface="Hiragino Sans W4" panose="020B0400000000000000" pitchFamily="34" charset="-128"/>
+                  <a:ea typeface="Hiragino Sans W4" panose="020B0400000000000000" pitchFamily="34" charset="-128"/>
+                </a:rPr>
+                <a:t>理想点</a:t>
+              </a:r>
+              <a:r>
+                <a:rPr kumimoji="1" lang="ja-JP" altLang="en-US" sz="2400">
+                  <a:latin typeface="Hiragino Sans W4" panose="020B0400000000000000" pitchFamily="34" charset="-128"/>
+                  <a:ea typeface="Hiragino Sans W4" panose="020B0400000000000000" pitchFamily="34" charset="-128"/>
+                </a:rPr>
+                <a:t>（</a:t>
+              </a:r>
+              <a:r>
+                <a:rPr kumimoji="1" lang="en-US" altLang="ja-JP" sz="2400" dirty="0">
+                  <a:latin typeface="Hiragino Sans W4" panose="020B0400000000000000" pitchFamily="34" charset="-128"/>
+                  <a:ea typeface="Hiragino Sans W4" panose="020B0400000000000000" pitchFamily="34" charset="-128"/>
+                </a:rPr>
+                <a:t>ideal point</a:t>
+              </a:r>
+              <a:r>
+                <a:rPr kumimoji="1" lang="ja-JP" altLang="en-US" sz="2400">
+                  <a:latin typeface="Hiragino Sans W4" panose="020B0400000000000000" pitchFamily="34" charset="-128"/>
+                  <a:ea typeface="Hiragino Sans W4" panose="020B0400000000000000" pitchFamily="34" charset="-128"/>
+                </a:rPr>
+                <a:t>）</a:t>
+              </a:r>
+              <a:endParaRPr kumimoji="1" lang="en-US" altLang="ja-JP" sz="2400" dirty="0">
+                <a:latin typeface="Hiragino Sans W4" panose="020B0400000000000000" pitchFamily="34" charset="-128"/>
+                <a:ea typeface="Hiragino Sans W4" panose="020B0400000000000000" pitchFamily="34" charset="-128"/>
+              </a:endParaRPr>
+            </a:p>
+            <a:p>
+              <a:r>
+                <a:rPr kumimoji="1" lang="ja-JP" altLang="en-US" sz="2400">
+                  <a:latin typeface="Hiragino Sans W4" panose="020B0400000000000000" pitchFamily="34" charset="-128"/>
+                  <a:ea typeface="Hiragino Sans W4" panose="020B0400000000000000" pitchFamily="34" charset="-128"/>
+                </a:rPr>
+                <a:t>＝各国にとって最も望ましい結果</a:t>
+              </a:r>
+            </a:p>
+          </p:txBody>
+        </p:sp>
+        <p:sp>
+          <p:nvSpPr>
+            <p:cNvPr id="18" name="テキスト ボックス 17">
+              <a:extLst>
+                <a:ext uri="{FF2B5EF4-FFF2-40B4-BE49-F238E27FC236}">
+                  <a16:creationId xmlns:a16="http://schemas.microsoft.com/office/drawing/2014/main" id="{8FC79F9D-8DCF-5373-C297-B45DB8017F1A}"/>
+                </a:ext>
+              </a:extLst>
+            </p:cNvPr>
+            <p:cNvSpPr txBox="1"/>
+            <p:nvPr/>
+          </p:nvSpPr>
+          <p:spPr>
+            <a:xfrm>
+              <a:off x="1107322" y="5588708"/>
+              <a:ext cx="5427385" cy="830997"/>
+            </a:xfrm>
+            <a:prstGeom prst="rect">
+              <a:avLst/>
+            </a:prstGeom>
+            <a:solidFill>
+              <a:schemeClr val="bg1"/>
+            </a:solidFill>
+            <a:ln>
+              <a:solidFill>
+                <a:schemeClr val="tx1"/>
+              </a:solidFill>
+            </a:ln>
+          </p:spPr>
+          <p:txBody>
+            <a:bodyPr wrap="square" rtlCol="0">
+              <a:spAutoFit/>
+            </a:bodyPr>
+            <a:lstStyle/>
+            <a:p>
+              <a:r>
+                <a:rPr kumimoji="1" lang="ja-JP" altLang="en-US" sz="2400" b="1">
+                  <a:latin typeface="Hiragino Sans W4" panose="020B0400000000000000" pitchFamily="34" charset="-128"/>
+                  <a:ea typeface="Hiragino Sans W4" panose="020B0400000000000000" pitchFamily="34" charset="-128"/>
+                </a:rPr>
+                <a:t>無差別曲線</a:t>
+              </a:r>
+              <a:r>
+                <a:rPr kumimoji="1" lang="ja-JP" altLang="en-US" sz="2400">
+                  <a:latin typeface="Hiragino Sans W4" panose="020B0400000000000000" pitchFamily="34" charset="-128"/>
+                  <a:ea typeface="Hiragino Sans W4" panose="020B0400000000000000" pitchFamily="34" charset="-128"/>
+                </a:rPr>
+                <a:t>（</a:t>
+              </a:r>
+              <a:r>
+                <a:rPr kumimoji="1" lang="en-US" altLang="ja-JP" sz="2400" dirty="0">
+                  <a:latin typeface="Hiragino Sans W4" panose="020B0400000000000000" pitchFamily="34" charset="-128"/>
+                  <a:ea typeface="Hiragino Sans W4" panose="020B0400000000000000" pitchFamily="34" charset="-128"/>
+                </a:rPr>
+                <a:t>indifference curve</a:t>
+              </a:r>
+              <a:r>
+                <a:rPr kumimoji="1" lang="ja-JP" altLang="en-US" sz="2400">
+                  <a:latin typeface="Hiragino Sans W4" panose="020B0400000000000000" pitchFamily="34" charset="-128"/>
+                  <a:ea typeface="Hiragino Sans W4" panose="020B0400000000000000" pitchFamily="34" charset="-128"/>
+                </a:rPr>
+                <a:t>）</a:t>
+              </a:r>
+              <a:endParaRPr kumimoji="1" lang="en-US" altLang="ja-JP" sz="2400" dirty="0">
+                <a:latin typeface="Hiragino Sans W4" panose="020B0400000000000000" pitchFamily="34" charset="-128"/>
+                <a:ea typeface="Hiragino Sans W4" panose="020B0400000000000000" pitchFamily="34" charset="-128"/>
+              </a:endParaRPr>
+            </a:p>
+            <a:p>
+              <a:r>
+                <a:rPr kumimoji="1" lang="ja-JP" altLang="en-US" sz="2400">
+                  <a:latin typeface="Hiragino Sans W4" panose="020B0400000000000000" pitchFamily="34" charset="-128"/>
+                  <a:ea typeface="Hiragino Sans W4" panose="020B0400000000000000" pitchFamily="34" charset="-128"/>
+                </a:rPr>
+                <a:t>＝各国にとっての受け入れ可能な範囲</a:t>
+              </a:r>
+            </a:p>
+          </p:txBody>
+        </p:sp>
+      </p:grpSp>
+    </p:spTree>
+    <p:extLst>
+      <p:ext uri="{BB962C8B-B14F-4D97-AF65-F5344CB8AC3E}">
+        <p14:creationId xmlns:p14="http://schemas.microsoft.com/office/powerpoint/2010/main" val="2536978197"/>
+      </p:ext>
+    </p:extLst>
+  </p:cSld>
+  <p:clrMapOvr>
+    <a:masterClrMapping/>
+  </p:clrMapOvr>
+</p:sld>
+</file>
+
+<file path=ppt/slides/slide8.xml><?xml version="1.0" encoding="utf-8"?>
+<p:sld xmlns:a="http://schemas.openxmlformats.org/drawingml/2006/main" xmlns:r="http://schemas.openxmlformats.org/officeDocument/2006/relationships" xmlns:p="http://schemas.openxmlformats.org/presentationml/2006/main">
+  <p:cSld>
+    <p:spTree>
+      <p:nvGrpSpPr>
+        <p:cNvPr id="1" name=""/>
+        <p:cNvGrpSpPr/>
+        <p:nvPr/>
+      </p:nvGrpSpPr>
+      <p:grpSpPr>
+        <a:xfrm>
+          <a:off x="0" y="0"/>
+          <a:ext cx="0" cy="0"/>
+          <a:chOff x="0" y="0"/>
+          <a:chExt cx="0" cy="0"/>
+        </a:xfrm>
+      </p:grpSpPr>
+      <p:grpSp>
+        <p:nvGrpSpPr>
+          <p:cNvPr id="27" name="グループ化 26">
+            <a:extLst>
+              <a:ext uri="{FF2B5EF4-FFF2-40B4-BE49-F238E27FC236}">
+                <a16:creationId xmlns:a16="http://schemas.microsoft.com/office/drawing/2014/main" id="{2D0E64CE-CDA6-3E7B-6763-43E891648623}"/>
+              </a:ext>
+            </a:extLst>
+          </p:cNvPr>
+          <p:cNvGrpSpPr/>
+          <p:nvPr/>
+        </p:nvGrpSpPr>
+        <p:grpSpPr>
+          <a:xfrm>
+            <a:off x="766152" y="390292"/>
+            <a:ext cx="9994775" cy="6304768"/>
+            <a:chOff x="766152" y="390292"/>
+            <a:chExt cx="9994775" cy="6304768"/>
+          </a:xfrm>
+        </p:grpSpPr>
+        <p:sp>
+          <p:nvSpPr>
+            <p:cNvPr id="21" name="フリーフォーム 20">
+              <a:extLst>
+                <a:ext uri="{FF2B5EF4-FFF2-40B4-BE49-F238E27FC236}">
+                  <a16:creationId xmlns:a16="http://schemas.microsoft.com/office/drawing/2014/main" id="{B1326135-3B09-5D0C-67BF-514AA535DBBF}"/>
+                </a:ext>
+              </a:extLst>
+            </p:cNvPr>
+            <p:cNvSpPr/>
+            <p:nvPr/>
+          </p:nvSpPr>
+          <p:spPr>
+            <a:xfrm>
+              <a:off x="5430308" y="2201557"/>
+              <a:ext cx="1100884" cy="2120735"/>
+            </a:xfrm>
+            <a:custGeom>
+              <a:avLst/>
+              <a:gdLst>
+                <a:gd name="csX0" fmla="*/ 1078073 w 1100884"/>
+                <a:gd name="csY0" fmla="*/ 0 h 2120735"/>
+                <a:gd name="csX1" fmla="*/ 1090093 w 1100884"/>
+                <a:gd name="csY1" fmla="*/ 78763 h 2120735"/>
+                <a:gd name="csX2" fmla="*/ 1100884 w 1100884"/>
+                <a:gd name="csY2" fmla="*/ 292465 h 2120735"/>
+                <a:gd name="csX3" fmla="*/ 179372 w 1100884"/>
+                <a:gd name="csY3" fmla="*/ 2025622 h 2120735"/>
+                <a:gd name="csX4" fmla="*/ 22812 w 1100884"/>
+                <a:gd name="csY4" fmla="*/ 2120735 h 2120735"/>
+                <a:gd name="csX5" fmla="*/ 10791 w 1100884"/>
+                <a:gd name="csY5" fmla="*/ 2041971 h 2120735"/>
+                <a:gd name="csX6" fmla="*/ 0 w 1100884"/>
+                <a:gd name="csY6" fmla="*/ 1828269 h 2120735"/>
+                <a:gd name="csX7" fmla="*/ 921513 w 1100884"/>
+                <a:gd name="csY7" fmla="*/ 95112 h 2120735"/>
+              </a:gdLst>
+              <a:ahLst/>
+              <a:cxnLst>
+                <a:cxn ang="0">
+                  <a:pos x="csX0" y="csY0"/>
+                </a:cxn>
+                <a:cxn ang="0">
+                  <a:pos x="csX1" y="csY1"/>
+                </a:cxn>
+                <a:cxn ang="0">
+                  <a:pos x="csX2" y="csY2"/>
+                </a:cxn>
+                <a:cxn ang="0">
+                  <a:pos x="csX3" y="csY3"/>
+                </a:cxn>
+                <a:cxn ang="0">
+                  <a:pos x="csX4" y="csY4"/>
+                </a:cxn>
+                <a:cxn ang="0">
+                  <a:pos x="csX5" y="csY5"/>
+                </a:cxn>
+                <a:cxn ang="0">
+                  <a:pos x="csX6" y="csY6"/>
+                </a:cxn>
+                <a:cxn ang="0">
+                  <a:pos x="csX7" y="csY7"/>
+                </a:cxn>
+              </a:cxnLst>
+              <a:rect l="l" t="t" r="r" b="b"/>
+              <a:pathLst>
+                <a:path w="1100884" h="2120735">
+                  <a:moveTo>
+                    <a:pt x="1078073" y="0"/>
+                  </a:moveTo>
+                  <a:lnTo>
+                    <a:pt x="1090093" y="78763"/>
+                  </a:lnTo>
+                  <a:cubicBezTo>
+                    <a:pt x="1097229" y="149027"/>
+                    <a:pt x="1100884" y="220319"/>
+                    <a:pt x="1100884" y="292465"/>
+                  </a:cubicBezTo>
+                  <a:cubicBezTo>
+                    <a:pt x="1100884" y="1013927"/>
+                    <a:pt x="735346" y="1650013"/>
+                    <a:pt x="179372" y="2025622"/>
+                  </a:cubicBezTo>
+                  <a:lnTo>
+                    <a:pt x="22812" y="2120735"/>
+                  </a:lnTo>
+                  <a:lnTo>
+                    <a:pt x="10791" y="2041971"/>
+                  </a:lnTo>
+                  <a:cubicBezTo>
+                    <a:pt x="3656" y="1971708"/>
+                    <a:pt x="0" y="1900415"/>
+                    <a:pt x="0" y="1828269"/>
+                  </a:cubicBezTo>
+                  <a:cubicBezTo>
+                    <a:pt x="0" y="1106807"/>
+                    <a:pt x="365538" y="470721"/>
+                    <a:pt x="921513" y="95112"/>
+                  </a:cubicBezTo>
+                  <a:close/>
+                </a:path>
+              </a:pathLst>
+            </a:custGeom>
+            <a:solidFill>
+              <a:srgbClr val="FF0000">
+                <a:alpha val="45999"/>
+              </a:srgbClr>
+            </a:solidFill>
+            <a:ln w="19050">
+              <a:noFill/>
+            </a:ln>
+          </p:spPr>
+          <p:style>
+            <a:lnRef idx="2">
+              <a:schemeClr val="accent1">
+                <a:shade val="15000"/>
+              </a:schemeClr>
+            </a:lnRef>
+            <a:fillRef idx="1">
+              <a:schemeClr val="accent1"/>
+            </a:fillRef>
+            <a:effectRef idx="0">
+              <a:schemeClr val="accent1"/>
+            </a:effectRef>
+            <a:fontRef idx="minor">
+              <a:schemeClr val="lt1"/>
+            </a:fontRef>
+          </p:style>
+          <p:txBody>
+            <a:bodyPr wrap="square" rtlCol="0" anchor="ctr">
+              <a:noAutofit/>
+            </a:bodyPr>
+            <a:lstStyle/>
+            <a:p>
+              <a:pPr algn="ctr"/>
+              <a:endParaRPr kumimoji="1" lang="ja-JP" altLang="en-US"/>
+            </a:p>
+          </p:txBody>
+        </p:sp>
+        <p:cxnSp>
+          <p:nvCxnSpPr>
+            <p:cNvPr id="3" name="直線矢印コネクタ 2">
+              <a:extLst>
+                <a:ext uri="{FF2B5EF4-FFF2-40B4-BE49-F238E27FC236}">
+                  <a16:creationId xmlns:a16="http://schemas.microsoft.com/office/drawing/2014/main" id="{F053167C-2D65-C1F4-DD2E-918546E80D30}"/>
+                </a:ext>
+              </a:extLst>
+            </p:cNvPr>
+            <p:cNvCxnSpPr>
+              <a:cxnSpLocks/>
+            </p:cNvCxnSpPr>
+            <p:nvPr/>
+          </p:nvCxnSpPr>
+          <p:spPr>
+            <a:xfrm>
+              <a:off x="1320150" y="6216979"/>
+              <a:ext cx="9440777" cy="0"/>
+            </a:xfrm>
+            <a:prstGeom prst="straightConnector1">
+              <a:avLst/>
+            </a:prstGeom>
+            <a:ln w="28575">
+              <a:solidFill>
+                <a:schemeClr val="tx1"/>
+              </a:solidFill>
+              <a:tailEnd type="triangle"/>
+            </a:ln>
+          </p:spPr>
+          <p:style>
+            <a:lnRef idx="1">
+              <a:schemeClr val="accent1"/>
+            </a:lnRef>
+            <a:fillRef idx="0">
+              <a:schemeClr val="accent1"/>
+            </a:fillRef>
+            <a:effectRef idx="0">
+              <a:schemeClr val="accent1"/>
+            </a:effectRef>
+            <a:fontRef idx="minor">
+              <a:schemeClr val="tx1"/>
+            </a:fontRef>
+          </p:style>
+        </p:cxnSp>
+        <p:cxnSp>
+          <p:nvCxnSpPr>
+            <p:cNvPr id="4" name="直線矢印コネクタ 3">
+              <a:extLst>
+                <a:ext uri="{FF2B5EF4-FFF2-40B4-BE49-F238E27FC236}">
+                  <a16:creationId xmlns:a16="http://schemas.microsoft.com/office/drawing/2014/main" id="{9AF80579-EA06-BAF8-035A-8E5FF46B6302}"/>
+                </a:ext>
+              </a:extLst>
+            </p:cNvPr>
+            <p:cNvCxnSpPr>
+              <a:cxnSpLocks/>
+            </p:cNvCxnSpPr>
+            <p:nvPr/>
+          </p:nvCxnSpPr>
+          <p:spPr>
+            <a:xfrm flipV="1">
+              <a:off x="1320150" y="390293"/>
+              <a:ext cx="0" cy="5826686"/>
+            </a:xfrm>
+            <a:prstGeom prst="straightConnector1">
+              <a:avLst/>
+            </a:prstGeom>
+            <a:ln w="28575">
+              <a:solidFill>
+                <a:schemeClr val="tx1"/>
+              </a:solidFill>
+              <a:tailEnd type="triangle"/>
+            </a:ln>
+          </p:spPr>
+          <p:style>
+            <a:lnRef idx="1">
+              <a:schemeClr val="accent1"/>
+            </a:lnRef>
+            <a:fillRef idx="0">
+              <a:schemeClr val="accent1"/>
+            </a:fillRef>
+            <a:effectRef idx="0">
+              <a:schemeClr val="accent1"/>
+            </a:effectRef>
+            <a:fontRef idx="minor">
+              <a:schemeClr val="tx1"/>
+            </a:fontRef>
+          </p:style>
+        </p:cxnSp>
+        <p:sp>
+          <p:nvSpPr>
+            <p:cNvPr id="5" name="テキスト ボックス 4">
+              <a:extLst>
+                <a:ext uri="{FF2B5EF4-FFF2-40B4-BE49-F238E27FC236}">
+                  <a16:creationId xmlns:a16="http://schemas.microsoft.com/office/drawing/2014/main" id="{E27D69AB-99C6-76D3-4974-4D040D287331}"/>
+                </a:ext>
+              </a:extLst>
+            </p:cNvPr>
+            <p:cNvSpPr txBox="1"/>
+            <p:nvPr/>
+          </p:nvSpPr>
+          <p:spPr>
+            <a:xfrm>
+              <a:off x="9248061" y="6233395"/>
+              <a:ext cx="1512866" cy="461665"/>
+            </a:xfrm>
+            <a:prstGeom prst="rect">
+              <a:avLst/>
+            </a:prstGeom>
+            <a:noFill/>
+          </p:spPr>
+          <p:txBody>
+            <a:bodyPr wrap="square" rtlCol="0">
+              <a:spAutoFit/>
+            </a:bodyPr>
+            <a:lstStyle/>
+            <a:p>
+              <a:pPr algn="ctr"/>
+              <a:r>
+                <a:rPr kumimoji="1" lang="ja-JP" altLang="en-US" sz="2400">
+                  <a:latin typeface="Hiragino Kaku Gothic StdN W8" panose="020B0800000000000000" pitchFamily="34" charset="-128"/>
+                  <a:ea typeface="Hiragino Kaku Gothic StdN W8" panose="020B0800000000000000" pitchFamily="34" charset="-128"/>
+                </a:rPr>
+                <a:t>車関税率</a:t>
+              </a:r>
+            </a:p>
+          </p:txBody>
+        </p:sp>
+        <p:sp>
+          <p:nvSpPr>
+            <p:cNvPr id="6" name="テキスト ボックス 5">
+              <a:extLst>
+                <a:ext uri="{FF2B5EF4-FFF2-40B4-BE49-F238E27FC236}">
+                  <a16:creationId xmlns:a16="http://schemas.microsoft.com/office/drawing/2014/main" id="{95FC9B2C-353A-C779-21AD-CC70229FCFF3}"/>
+                </a:ext>
+              </a:extLst>
+            </p:cNvPr>
+            <p:cNvSpPr txBox="1"/>
+            <p:nvPr/>
+          </p:nvSpPr>
+          <p:spPr>
+            <a:xfrm>
+              <a:off x="766152" y="390292"/>
+              <a:ext cx="553998" cy="1323439"/>
+            </a:xfrm>
+            <a:prstGeom prst="rect">
+              <a:avLst/>
+            </a:prstGeom>
+            <a:noFill/>
+          </p:spPr>
+          <p:txBody>
+            <a:bodyPr vert="eaVert" wrap="none" rtlCol="0">
+              <a:spAutoFit/>
+            </a:bodyPr>
+            <a:lstStyle/>
+            <a:p>
+              <a:r>
+                <a:rPr kumimoji="1" lang="ja-JP" altLang="en-US" sz="2400">
+                  <a:latin typeface="Hiragino Kaku Gothic StdN W8" panose="020B0800000000000000" pitchFamily="34" charset="-128"/>
+                  <a:ea typeface="Hiragino Kaku Gothic StdN W8" panose="020B0800000000000000" pitchFamily="34" charset="-128"/>
+                </a:rPr>
+                <a:t>肉関税率</a:t>
+              </a:r>
+            </a:p>
+          </p:txBody>
+        </p:sp>
+        <p:sp>
+          <p:nvSpPr>
+            <p:cNvPr id="15" name="円/楕円 14">
+              <a:extLst>
+                <a:ext uri="{FF2B5EF4-FFF2-40B4-BE49-F238E27FC236}">
+                  <a16:creationId xmlns:a16="http://schemas.microsoft.com/office/drawing/2014/main" id="{9BCA4DC2-E16D-3947-E359-71719137B8DF}"/>
+                </a:ext>
+              </a:extLst>
+            </p:cNvPr>
+            <p:cNvSpPr/>
+            <p:nvPr/>
+          </p:nvSpPr>
+          <p:spPr>
+            <a:xfrm>
+              <a:off x="4369695" y="2364273"/>
+              <a:ext cx="186550" cy="186550"/>
+            </a:xfrm>
+            <a:prstGeom prst="ellipse">
+              <a:avLst/>
+            </a:prstGeom>
+            <a:solidFill>
+              <a:schemeClr val="tx1"/>
+            </a:solidFill>
+            <a:ln>
+              <a:noFill/>
+            </a:ln>
+          </p:spPr>
+          <p:style>
+            <a:lnRef idx="2">
+              <a:schemeClr val="accent1">
+                <a:shade val="50000"/>
+              </a:schemeClr>
+            </a:lnRef>
+            <a:fillRef idx="1">
+              <a:schemeClr val="accent1"/>
+            </a:fillRef>
+            <a:effectRef idx="0">
+              <a:schemeClr val="accent1"/>
+            </a:effectRef>
+            <a:fontRef idx="minor">
+              <a:schemeClr val="lt1"/>
+            </a:fontRef>
+          </p:style>
+          <p:txBody>
+            <a:bodyPr rtlCol="0" anchor="ctr"/>
+            <a:lstStyle/>
+            <a:p>
+              <a:pPr algn="ctr"/>
+              <a:endParaRPr kumimoji="1" lang="ja-JP" altLang="en-US"/>
+            </a:p>
+          </p:txBody>
+        </p:sp>
+        <p:sp>
+          <p:nvSpPr>
+            <p:cNvPr id="16" name="テキスト ボックス 15">
+              <a:extLst>
+                <a:ext uri="{FF2B5EF4-FFF2-40B4-BE49-F238E27FC236}">
+                  <a16:creationId xmlns:a16="http://schemas.microsoft.com/office/drawing/2014/main" id="{0535611D-3D6A-35D7-617C-4EBCBE257007}"/>
+                </a:ext>
+              </a:extLst>
+            </p:cNvPr>
+            <p:cNvSpPr txBox="1"/>
+            <p:nvPr/>
+          </p:nvSpPr>
+          <p:spPr>
+            <a:xfrm>
+              <a:off x="3915337" y="2558199"/>
+              <a:ext cx="1024577" cy="461665"/>
+            </a:xfrm>
+            <a:prstGeom prst="rect">
+              <a:avLst/>
+            </a:prstGeom>
+            <a:noFill/>
+          </p:spPr>
+          <p:txBody>
+            <a:bodyPr wrap="square" rtlCol="0">
+              <a:spAutoFit/>
+            </a:bodyPr>
+            <a:lstStyle/>
+            <a:p>
+              <a:pPr algn="ctr"/>
+              <a:r>
+                <a:rPr kumimoji="1" lang="ja-JP" altLang="en-US" sz="2400">
+                  <a:latin typeface="Hiragino Kaku Gothic StdN W8" panose="020B0800000000000000" pitchFamily="34" charset="-128"/>
+                  <a:ea typeface="Hiragino Kaku Gothic StdN W8" panose="020B0800000000000000" pitchFamily="34" charset="-128"/>
+                </a:rPr>
+                <a:t>日本</a:t>
+              </a:r>
+            </a:p>
+          </p:txBody>
+        </p:sp>
+        <p:sp>
+          <p:nvSpPr>
+            <p:cNvPr id="17" name="円/楕円 16">
+              <a:extLst>
+                <a:ext uri="{FF2B5EF4-FFF2-40B4-BE49-F238E27FC236}">
+                  <a16:creationId xmlns:a16="http://schemas.microsoft.com/office/drawing/2014/main" id="{BB147123-0E8F-2C10-0C77-34492678BE04}"/>
+                </a:ext>
+              </a:extLst>
+            </p:cNvPr>
+            <p:cNvSpPr/>
+            <p:nvPr/>
+          </p:nvSpPr>
+          <p:spPr>
+            <a:xfrm>
+              <a:off x="2354479" y="390292"/>
+              <a:ext cx="4180231" cy="4180231"/>
+            </a:xfrm>
+            <a:prstGeom prst="ellipse">
+              <a:avLst/>
+            </a:prstGeom>
+            <a:noFill/>
+            <a:ln w="19050">
+              <a:solidFill>
+                <a:schemeClr val="tx1"/>
+              </a:solidFill>
+            </a:ln>
+          </p:spPr>
+          <p:style>
+            <a:lnRef idx="2">
+              <a:schemeClr val="accent1">
+                <a:shade val="15000"/>
+              </a:schemeClr>
+            </a:lnRef>
+            <a:fillRef idx="1">
+              <a:schemeClr val="accent1"/>
+            </a:fillRef>
+            <a:effectRef idx="0">
+              <a:schemeClr val="accent1"/>
+            </a:effectRef>
+            <a:fontRef idx="minor">
+              <a:schemeClr val="lt1"/>
+            </a:fontRef>
+          </p:style>
+          <p:txBody>
+            <a:bodyPr rtlCol="0" anchor="ctr"/>
+            <a:lstStyle/>
+            <a:p>
+              <a:pPr algn="ctr"/>
+              <a:endParaRPr kumimoji="1" lang="ja-JP" altLang="en-US"/>
+            </a:p>
+          </p:txBody>
+        </p:sp>
+        <p:sp>
+          <p:nvSpPr>
+            <p:cNvPr id="12" name="テキスト ボックス 11">
+              <a:extLst>
+                <a:ext uri="{FF2B5EF4-FFF2-40B4-BE49-F238E27FC236}">
+                  <a16:creationId xmlns:a16="http://schemas.microsoft.com/office/drawing/2014/main" id="{CEB6F196-94AD-3346-91C5-54606213F811}"/>
+                </a:ext>
+              </a:extLst>
+            </p:cNvPr>
+            <p:cNvSpPr txBox="1"/>
+            <p:nvPr/>
+          </p:nvSpPr>
+          <p:spPr>
+            <a:xfrm>
+              <a:off x="6996337" y="4091460"/>
+              <a:ext cx="1024577" cy="461665"/>
+            </a:xfrm>
+            <a:prstGeom prst="rect">
+              <a:avLst/>
+            </a:prstGeom>
+            <a:noFill/>
+          </p:spPr>
+          <p:txBody>
+            <a:bodyPr wrap="square" rtlCol="0">
+              <a:spAutoFit/>
+            </a:bodyPr>
+            <a:lstStyle/>
+            <a:p>
+              <a:r>
+                <a:rPr kumimoji="1" lang="ja-JP" altLang="en-US" sz="2400">
+                  <a:latin typeface="Hiragino Kaku Gothic StdN W8" panose="020B0800000000000000" pitchFamily="34" charset="-128"/>
+                  <a:ea typeface="Hiragino Kaku Gothic StdN W8" panose="020B0800000000000000" pitchFamily="34" charset="-128"/>
+                </a:rPr>
+                <a:t>米国</a:t>
+              </a:r>
+            </a:p>
+          </p:txBody>
+        </p:sp>
+        <p:sp>
+          <p:nvSpPr>
+            <p:cNvPr id="13" name="円/楕円 12">
+              <a:extLst>
+                <a:ext uri="{FF2B5EF4-FFF2-40B4-BE49-F238E27FC236}">
+                  <a16:creationId xmlns:a16="http://schemas.microsoft.com/office/drawing/2014/main" id="{1BAB4AA8-156E-4D83-DA59-4C6F2A7F254C}"/>
+                </a:ext>
+              </a:extLst>
+            </p:cNvPr>
+            <p:cNvSpPr/>
+            <p:nvPr/>
+          </p:nvSpPr>
+          <p:spPr>
+            <a:xfrm>
+              <a:off x="7450695" y="3920436"/>
+              <a:ext cx="186550" cy="186550"/>
+            </a:xfrm>
+            <a:prstGeom prst="ellipse">
+              <a:avLst/>
+            </a:prstGeom>
+            <a:solidFill>
+              <a:schemeClr val="tx1"/>
+            </a:solidFill>
+            <a:ln>
+              <a:noFill/>
+            </a:ln>
+          </p:spPr>
+          <p:style>
+            <a:lnRef idx="2">
+              <a:schemeClr val="accent1">
+                <a:shade val="50000"/>
+              </a:schemeClr>
+            </a:lnRef>
+            <a:fillRef idx="1">
+              <a:schemeClr val="accent1"/>
+            </a:fillRef>
+            <a:effectRef idx="0">
+              <a:schemeClr val="accent1"/>
+            </a:effectRef>
+            <a:fontRef idx="minor">
+              <a:schemeClr val="lt1"/>
+            </a:fontRef>
+          </p:style>
+          <p:txBody>
+            <a:bodyPr rtlCol="0" anchor="ctr"/>
+            <a:lstStyle/>
+            <a:p>
+              <a:pPr algn="ctr"/>
+              <a:endParaRPr kumimoji="1" lang="ja-JP" altLang="en-US"/>
+            </a:p>
+          </p:txBody>
+        </p:sp>
+        <p:sp>
+          <p:nvSpPr>
+            <p:cNvPr id="14" name="円/楕円 13">
+              <a:extLst>
+                <a:ext uri="{FF2B5EF4-FFF2-40B4-BE49-F238E27FC236}">
+                  <a16:creationId xmlns:a16="http://schemas.microsoft.com/office/drawing/2014/main" id="{A283B04F-6648-3F29-F787-5058E4E59D24}"/>
+                </a:ext>
+              </a:extLst>
+            </p:cNvPr>
+            <p:cNvSpPr/>
+            <p:nvPr/>
+          </p:nvSpPr>
+          <p:spPr>
+            <a:xfrm>
+              <a:off x="5433827" y="1926096"/>
+              <a:ext cx="4180231" cy="4180231"/>
+            </a:xfrm>
+            <a:prstGeom prst="ellipse">
+              <a:avLst/>
+            </a:prstGeom>
+            <a:noFill/>
+            <a:ln w="19050">
+              <a:solidFill>
+                <a:schemeClr val="tx1"/>
+              </a:solidFill>
+            </a:ln>
+          </p:spPr>
+          <p:style>
+            <a:lnRef idx="2">
+              <a:schemeClr val="accent1">
+                <a:shade val="15000"/>
+              </a:schemeClr>
+            </a:lnRef>
+            <a:fillRef idx="1">
+              <a:schemeClr val="accent1"/>
+            </a:fillRef>
+            <a:effectRef idx="0">
+              <a:schemeClr val="accent1"/>
+            </a:effectRef>
+            <a:fontRef idx="minor">
+              <a:schemeClr val="lt1"/>
+            </a:fontRef>
+          </p:style>
+          <p:txBody>
+            <a:bodyPr rtlCol="0" anchor="ctr"/>
+            <a:lstStyle/>
+            <a:p>
+              <a:pPr algn="ctr"/>
+              <a:endParaRPr kumimoji="1" lang="ja-JP" altLang="en-US"/>
+            </a:p>
+          </p:txBody>
+        </p:sp>
+        <p:grpSp>
+          <p:nvGrpSpPr>
+            <p:cNvPr id="9" name="グループ化 8">
+              <a:extLst>
+                <a:ext uri="{FF2B5EF4-FFF2-40B4-BE49-F238E27FC236}">
+                  <a16:creationId xmlns:a16="http://schemas.microsoft.com/office/drawing/2014/main" id="{C6FE73ED-90C9-E426-45AA-C15FF1B35F81}"/>
+                </a:ext>
+              </a:extLst>
+            </p:cNvPr>
+            <p:cNvGrpSpPr/>
+            <p:nvPr/>
+          </p:nvGrpSpPr>
+          <p:grpSpPr>
+            <a:xfrm>
+              <a:off x="6270771" y="1711020"/>
+              <a:ext cx="1024577" cy="555608"/>
+              <a:chOff x="6270771" y="1711020"/>
+              <a:chExt cx="1024577" cy="555608"/>
+            </a:xfrm>
+          </p:grpSpPr>
+          <p:sp>
+            <p:nvSpPr>
+              <p:cNvPr id="10" name="テキスト ボックス 9">
+                <a:extLst>
+                  <a:ext uri="{FF2B5EF4-FFF2-40B4-BE49-F238E27FC236}">
+                    <a16:creationId xmlns:a16="http://schemas.microsoft.com/office/drawing/2014/main" id="{9B0B7F9D-1073-76F1-CFB2-9AB6ED7296ED}"/>
+                  </a:ext>
+                </a:extLst>
+              </p:cNvPr>
+              <p:cNvSpPr txBox="1"/>
+              <p:nvPr/>
+            </p:nvSpPr>
+            <p:spPr>
+              <a:xfrm>
+                <a:off x="6270771" y="1711020"/>
+                <a:ext cx="1024577" cy="461665"/>
+              </a:xfrm>
+              <a:prstGeom prst="rect">
+                <a:avLst/>
+              </a:prstGeom>
+              <a:noFill/>
+            </p:spPr>
+            <p:txBody>
+              <a:bodyPr wrap="square" rtlCol="0">
+                <a:spAutoFit/>
+              </a:bodyPr>
+              <a:lstStyle/>
+              <a:p>
+                <a:r>
+                  <a:rPr kumimoji="1" lang="ja-JP" altLang="en-US" sz="2400">
+                    <a:latin typeface="Hiragino Kaku Gothic StdN W8" panose="020B0800000000000000" pitchFamily="34" charset="-128"/>
+                    <a:ea typeface="Hiragino Kaku Gothic StdN W8" panose="020B0800000000000000" pitchFamily="34" charset="-128"/>
+                  </a:rPr>
+                  <a:t>現状</a:t>
+                </a:r>
+              </a:p>
+            </p:txBody>
+          </p:sp>
+          <p:sp>
+            <p:nvSpPr>
+              <p:cNvPr id="11" name="円/楕円 10">
+                <a:extLst>
+                  <a:ext uri="{FF2B5EF4-FFF2-40B4-BE49-F238E27FC236}">
+                    <a16:creationId xmlns:a16="http://schemas.microsoft.com/office/drawing/2014/main" id="{192FAEB4-7B5F-9F13-4D7D-3C0C5612F497}"/>
+                  </a:ext>
+                </a:extLst>
+              </p:cNvPr>
+              <p:cNvSpPr/>
+              <p:nvPr/>
+            </p:nvSpPr>
+            <p:spPr>
+              <a:xfrm>
+                <a:off x="6419541" y="2080078"/>
+                <a:ext cx="186550" cy="186550"/>
+              </a:xfrm>
+              <a:prstGeom prst="ellipse">
+                <a:avLst/>
+              </a:prstGeom>
+              <a:solidFill>
+                <a:schemeClr val="tx1"/>
+              </a:solidFill>
+              <a:ln>
+                <a:noFill/>
+              </a:ln>
+            </p:spPr>
+            <p:style>
+              <a:lnRef idx="2">
+                <a:schemeClr val="accent1">
+                  <a:shade val="50000"/>
+                </a:schemeClr>
+              </a:lnRef>
+              <a:fillRef idx="1">
+                <a:schemeClr val="accent1"/>
+              </a:fillRef>
+              <a:effectRef idx="0">
+                <a:schemeClr val="accent1"/>
+              </a:effectRef>
+              <a:fontRef idx="minor">
+                <a:schemeClr val="lt1"/>
+              </a:fontRef>
+            </p:style>
+            <p:txBody>
+              <a:bodyPr rtlCol="0" anchor="ctr"/>
+              <a:lstStyle/>
+              <a:p>
+                <a:pPr algn="ctr"/>
+                <a:endParaRPr kumimoji="1" lang="ja-JP" altLang="en-US"/>
+              </a:p>
+            </p:txBody>
+          </p:sp>
+        </p:grpSp>
+        <p:cxnSp>
+          <p:nvCxnSpPr>
+            <p:cNvPr id="22" name="直線矢印コネクタ 21">
+              <a:extLst>
+                <a:ext uri="{FF2B5EF4-FFF2-40B4-BE49-F238E27FC236}">
+                  <a16:creationId xmlns:a16="http://schemas.microsoft.com/office/drawing/2014/main" id="{D6819D70-EBE4-EC0B-D5B4-24573AAB134C}"/>
+                </a:ext>
+              </a:extLst>
+            </p:cNvPr>
+            <p:cNvCxnSpPr>
+              <a:cxnSpLocks/>
+              <a:stCxn id="23" idx="0"/>
+              <a:endCxn id="14" idx="2"/>
+            </p:cNvCxnSpPr>
+            <p:nvPr/>
+          </p:nvCxnSpPr>
+          <p:spPr>
+            <a:xfrm flipV="1">
+              <a:off x="4033842" y="4016212"/>
+              <a:ext cx="1399985" cy="728124"/>
+            </a:xfrm>
+            <a:prstGeom prst="straightConnector1">
+              <a:avLst/>
+            </a:prstGeom>
+            <a:ln w="57150">
+              <a:solidFill>
+                <a:schemeClr val="tx1"/>
+              </a:solidFill>
+              <a:tailEnd type="triangle"/>
+            </a:ln>
+          </p:spPr>
+          <p:style>
+            <a:lnRef idx="1">
+              <a:schemeClr val="accent1"/>
+            </a:lnRef>
+            <a:fillRef idx="0">
+              <a:schemeClr val="accent1"/>
+            </a:fillRef>
+            <a:effectRef idx="0">
+              <a:schemeClr val="accent1"/>
+            </a:effectRef>
+            <a:fontRef idx="minor">
+              <a:schemeClr val="tx1"/>
+            </a:fontRef>
+          </p:style>
+        </p:cxnSp>
+        <p:sp>
+          <p:nvSpPr>
+            <p:cNvPr id="23" name="テキスト ボックス 22">
+              <a:extLst>
+                <a:ext uri="{FF2B5EF4-FFF2-40B4-BE49-F238E27FC236}">
+                  <a16:creationId xmlns:a16="http://schemas.microsoft.com/office/drawing/2014/main" id="{41CE7F9A-23B9-95EB-A64E-46AEAEE2F35F}"/>
+                </a:ext>
+              </a:extLst>
+            </p:cNvPr>
+            <p:cNvSpPr txBox="1"/>
+            <p:nvPr/>
+          </p:nvSpPr>
+          <p:spPr>
+            <a:xfrm>
+              <a:off x="1320149" y="4744336"/>
+              <a:ext cx="5427385" cy="1569660"/>
+            </a:xfrm>
+            <a:prstGeom prst="rect">
+              <a:avLst/>
+            </a:prstGeom>
+            <a:solidFill>
+              <a:schemeClr val="bg1"/>
+            </a:solidFill>
+            <a:ln>
+              <a:solidFill>
+                <a:schemeClr val="tx1"/>
+              </a:solidFill>
+            </a:ln>
+          </p:spPr>
+          <p:txBody>
+            <a:bodyPr wrap="square" rtlCol="0">
+              <a:spAutoFit/>
+            </a:bodyPr>
+            <a:lstStyle/>
+            <a:p>
+              <a:r>
+                <a:rPr kumimoji="1" lang="ja-JP" altLang="en-US" sz="2400" b="1">
+                  <a:latin typeface="Hiragino Sans W4" panose="020B0400000000000000" pitchFamily="34" charset="-128"/>
+                  <a:ea typeface="Hiragino Sans W4" panose="020B0400000000000000" pitchFamily="34" charset="-128"/>
+                </a:rPr>
+                <a:t>勝利集合</a:t>
+              </a:r>
+              <a:r>
+                <a:rPr kumimoji="1" lang="ja-JP" altLang="en-US" sz="2400">
+                  <a:latin typeface="Hiragino Sans W4" panose="020B0400000000000000" pitchFamily="34" charset="-128"/>
+                  <a:ea typeface="Hiragino Sans W4" panose="020B0400000000000000" pitchFamily="34" charset="-128"/>
+                </a:rPr>
+                <a:t>（</a:t>
+              </a:r>
+              <a:r>
+                <a:rPr kumimoji="1" lang="en-US" altLang="ja-JP" sz="2400" dirty="0" err="1">
+                  <a:latin typeface="Hiragino Sans W4" panose="020B0400000000000000" pitchFamily="34" charset="-128"/>
+                  <a:ea typeface="Hiragino Sans W4" panose="020B0400000000000000" pitchFamily="34" charset="-128"/>
+                </a:rPr>
+                <a:t>winset</a:t>
+              </a:r>
+              <a:r>
+                <a:rPr kumimoji="1" lang="ja-JP" altLang="en-US" sz="2400">
+                  <a:latin typeface="Hiragino Sans W4" panose="020B0400000000000000" pitchFamily="34" charset="-128"/>
+                  <a:ea typeface="Hiragino Sans W4" panose="020B0400000000000000" pitchFamily="34" charset="-128"/>
+                </a:rPr>
+                <a:t>）</a:t>
+              </a:r>
+              <a:endParaRPr kumimoji="1" lang="en-US" altLang="ja-JP" sz="2400" dirty="0">
+                <a:latin typeface="Hiragino Sans W4" panose="020B0400000000000000" pitchFamily="34" charset="-128"/>
+                <a:ea typeface="Hiragino Sans W4" panose="020B0400000000000000" pitchFamily="34" charset="-128"/>
+              </a:endParaRPr>
+            </a:p>
+            <a:p>
+              <a:r>
+                <a:rPr kumimoji="1" lang="ja-JP" altLang="en-US" sz="2400">
+                  <a:latin typeface="Hiragino Sans W4" panose="020B0400000000000000" pitchFamily="34" charset="-128"/>
+                  <a:ea typeface="Hiragino Sans W4" panose="020B0400000000000000" pitchFamily="34" charset="-128"/>
+                </a:rPr>
+                <a:t>＝両者が合意できる範囲</a:t>
+              </a:r>
+              <a:endParaRPr kumimoji="1" lang="en-US" altLang="ja-JP" sz="2400" dirty="0">
+                <a:latin typeface="Hiragino Sans W4" panose="020B0400000000000000" pitchFamily="34" charset="-128"/>
+                <a:ea typeface="Hiragino Sans W4" panose="020B0400000000000000" pitchFamily="34" charset="-128"/>
+              </a:endParaRPr>
+            </a:p>
+            <a:p>
+              <a:pPr marL="342900" indent="-342900">
+                <a:buFont typeface="Arial" panose="020B0604020202020204" pitchFamily="34" charset="0"/>
+                <a:buChar char="•"/>
+              </a:pPr>
+              <a:r>
+                <a:rPr kumimoji="1" lang="ja-JP" altLang="en-US" sz="2400">
+                  <a:latin typeface="Hiragino Sans W4" panose="020B0400000000000000" pitchFamily="34" charset="-128"/>
+                  <a:ea typeface="Hiragino Sans W4" panose="020B0400000000000000" pitchFamily="34" charset="-128"/>
+                </a:rPr>
+                <a:t>現状よりも望ましい</a:t>
+              </a:r>
+              <a:endParaRPr kumimoji="1" lang="en-US" altLang="ja-JP" sz="2400" dirty="0">
+                <a:latin typeface="Hiragino Sans W4" panose="020B0400000000000000" pitchFamily="34" charset="-128"/>
+                <a:ea typeface="Hiragino Sans W4" panose="020B0400000000000000" pitchFamily="34" charset="-128"/>
+              </a:endParaRPr>
+            </a:p>
+            <a:p>
+              <a:pPr marL="342900" indent="-342900">
+                <a:buFont typeface="Arial" panose="020B0604020202020204" pitchFamily="34" charset="0"/>
+                <a:buChar char="•"/>
+              </a:pPr>
+              <a:r>
+                <a:rPr lang="ja-JP" altLang="en-US" sz="2400">
+                  <a:latin typeface="Hiragino Sans W4" panose="020B0400000000000000" pitchFamily="34" charset="-128"/>
+                  <a:ea typeface="Hiragino Sans W4" panose="020B0400000000000000" pitchFamily="34" charset="-128"/>
+                </a:rPr>
+                <a:t>広さが合意のしやすさを表す</a:t>
+              </a:r>
+              <a:endParaRPr kumimoji="1" lang="ja-JP" altLang="en-US" sz="2400">
+                <a:latin typeface="Hiragino Sans W4" panose="020B0400000000000000" pitchFamily="34" charset="-128"/>
+                <a:ea typeface="Hiragino Sans W4" panose="020B0400000000000000" pitchFamily="34" charset="-128"/>
+              </a:endParaRPr>
+            </a:p>
+          </p:txBody>
+        </p:sp>
+      </p:grpSp>
+    </p:spTree>
+    <p:extLst>
+      <p:ext uri="{BB962C8B-B14F-4D97-AF65-F5344CB8AC3E}">
+        <p14:creationId xmlns:p14="http://schemas.microsoft.com/office/powerpoint/2010/main" val="2567997111"/>
+      </p:ext>
+    </p:extLst>
+  </p:cSld>
+  <p:clrMapOvr>
+    <a:masterClrMapping/>
+  </p:clrMapOvr>
+</p:sld>
+</file>
+
+<file path=ppt/slides/slide9.xml><?xml version="1.0" encoding="utf-8"?>
+<p:sld xmlns:a="http://schemas.openxmlformats.org/drawingml/2006/main" xmlns:r="http://schemas.openxmlformats.org/officeDocument/2006/relationships" xmlns:p="http://schemas.openxmlformats.org/presentationml/2006/main">
+  <p:cSld>
+    <p:spTree>
+      <p:nvGrpSpPr>
+        <p:cNvPr id="1" name=""/>
+        <p:cNvGrpSpPr/>
+        <p:nvPr/>
+      </p:nvGrpSpPr>
+      <p:grpSpPr>
+        <a:xfrm>
+          <a:off x="0" y="0"/>
+          <a:ext cx="0" cy="0"/>
+          <a:chOff x="0" y="0"/>
+          <a:chExt cx="0" cy="0"/>
+        </a:xfrm>
+      </p:grpSpPr>
+      <p:grpSp>
+        <p:nvGrpSpPr>
+          <p:cNvPr id="58" name="グループ化 57">
+            <a:extLst>
+              <a:ext uri="{FF2B5EF4-FFF2-40B4-BE49-F238E27FC236}">
+                <a16:creationId xmlns:a16="http://schemas.microsoft.com/office/drawing/2014/main" id="{8C50C00B-D171-09FE-6CA8-E94F2CB13D43}"/>
+              </a:ext>
+            </a:extLst>
+          </p:cNvPr>
+          <p:cNvGrpSpPr/>
+          <p:nvPr/>
+        </p:nvGrpSpPr>
+        <p:grpSpPr>
+          <a:xfrm>
+            <a:off x="766152" y="390292"/>
+            <a:ext cx="9994775" cy="6304768"/>
+            <a:chOff x="766152" y="390292"/>
+            <a:chExt cx="9994775" cy="6304768"/>
+          </a:xfrm>
+        </p:grpSpPr>
+        <p:sp>
+          <p:nvSpPr>
+            <p:cNvPr id="52" name="フリーフォーム 51">
+              <a:extLst>
+                <a:ext uri="{FF2B5EF4-FFF2-40B4-BE49-F238E27FC236}">
+                  <a16:creationId xmlns:a16="http://schemas.microsoft.com/office/drawing/2014/main" id="{B84C41E5-FE30-59A8-EB75-54D7B6459018}"/>
+                </a:ext>
+              </a:extLst>
+            </p:cNvPr>
+            <p:cNvSpPr/>
+            <p:nvPr/>
+          </p:nvSpPr>
+          <p:spPr>
+            <a:xfrm>
+              <a:off x="4665375" y="1532167"/>
+              <a:ext cx="1859303" cy="2975393"/>
+            </a:xfrm>
+            <a:custGeom>
+              <a:avLst/>
+              <a:gdLst>
+                <a:gd name="csX0" fmla="*/ 1827440 w 1859303"/>
+                <a:gd name="csY0" fmla="*/ 1298000 h 2975393"/>
+                <a:gd name="csX1" fmla="*/ 1819666 w 1859303"/>
+                <a:gd name="csY1" fmla="*/ 1346839 h 2975393"/>
+                <a:gd name="csX2" fmla="*/ 935553 w 1859303"/>
+                <a:gd name="csY2" fmla="*/ 2684332 h 2975393"/>
+                <a:gd name="csX3" fmla="*/ 778993 w 1859303"/>
+                <a:gd name="csY3" fmla="*/ 2779445 h 2975393"/>
+                <a:gd name="csX4" fmla="*/ 776932 w 1859303"/>
+                <a:gd name="csY4" fmla="*/ 2765944 h 2975393"/>
+                <a:gd name="csX5" fmla="*/ 842194 w 1859303"/>
+                <a:gd name="csY5" fmla="*/ 2730240 h 2975393"/>
+                <a:gd name="csX6" fmla="*/ 1796685 w 1859303"/>
+                <a:gd name="csY6" fmla="*/ 1446018 h 2975393"/>
+                <a:gd name="csX7" fmla="*/ 1834091 w 1859303"/>
+                <a:gd name="csY7" fmla="*/ 1256216 h 2975393"/>
+                <a:gd name="csX8" fmla="*/ 1831097 w 1859303"/>
+                <a:gd name="csY8" fmla="*/ 1280400 h 2975393"/>
+                <a:gd name="csX9" fmla="*/ 1827440 w 1859303"/>
+                <a:gd name="csY9" fmla="*/ 1298000 h 2975393"/>
+                <a:gd name="csX10" fmla="*/ 1844827 w 1859303"/>
+                <a:gd name="csY10" fmla="*/ 1169487 h 2975393"/>
+                <a:gd name="csX11" fmla="*/ 1840272 w 1859303"/>
+                <a:gd name="csY11" fmla="*/ 1217379 h 2975393"/>
+                <a:gd name="csX12" fmla="*/ 1834091 w 1859303"/>
+                <a:gd name="csY12" fmla="*/ 1256216 h 2975393"/>
+                <a:gd name="csX13" fmla="*/ 1635975 w 1859303"/>
+                <a:gd name="csY13" fmla="*/ 0 h 2975393"/>
+                <a:gd name="csX14" fmla="*/ 1695052 w 1859303"/>
+                <a:gd name="csY14" fmla="*/ 122635 h 2975393"/>
+                <a:gd name="csX15" fmla="*/ 1859303 w 1859303"/>
+                <a:gd name="csY15" fmla="*/ 936202 h 2975393"/>
+                <a:gd name="csX16" fmla="*/ 1852158 w 1859303"/>
+                <a:gd name="csY16" fmla="*/ 1110274 h 2975393"/>
+                <a:gd name="csX17" fmla="*/ 1844827 w 1859303"/>
+                <a:gd name="csY17" fmla="*/ 1169487 h 2975393"/>
+                <a:gd name="csX18" fmla="*/ 1852824 w 1859303"/>
+                <a:gd name="csY18" fmla="*/ 1085406 h 2975393"/>
+                <a:gd name="csX19" fmla="*/ 1857065 w 1859303"/>
+                <a:gd name="csY19" fmla="*/ 951175 h 2975393"/>
+                <a:gd name="csX20" fmla="*/ 1846274 w 1859303"/>
+                <a:gd name="csY20" fmla="*/ 737473 h 2975393"/>
+                <a:gd name="csX21" fmla="*/ 1834254 w 1859303"/>
+                <a:gd name="csY21" fmla="*/ 658710 h 2975393"/>
+                <a:gd name="csX22" fmla="*/ 1677694 w 1859303"/>
+                <a:gd name="csY22" fmla="*/ 753822 h 2975393"/>
+                <a:gd name="csX23" fmla="*/ 756181 w 1859303"/>
+                <a:gd name="csY23" fmla="*/ 2486979 h 2975393"/>
+                <a:gd name="csX24" fmla="*/ 766972 w 1859303"/>
+                <a:gd name="csY24" fmla="*/ 2700681 h 2975393"/>
+                <a:gd name="csX25" fmla="*/ 776932 w 1859303"/>
+                <a:gd name="csY25" fmla="*/ 2765944 h 2975393"/>
+                <a:gd name="csX26" fmla="*/ 698105 w 1859303"/>
+                <a:gd name="csY26" fmla="*/ 2809069 h 2975393"/>
+                <a:gd name="csX27" fmla="*/ 390724 w 1859303"/>
+                <a:gd name="csY27" fmla="*/ 2932351 h 2975393"/>
+                <a:gd name="csX28" fmla="*/ 223328 w 1859303"/>
+                <a:gd name="csY28" fmla="*/ 2975393 h 2975393"/>
+                <a:gd name="csX29" fmla="*/ 164252 w 1859303"/>
+                <a:gd name="csY29" fmla="*/ 2852758 h 2975393"/>
+                <a:gd name="csX30" fmla="*/ 0 w 1859303"/>
+                <a:gd name="csY30" fmla="*/ 2039190 h 2975393"/>
+                <a:gd name="csX31" fmla="*/ 1468580 w 1859303"/>
+                <a:gd name="csY31" fmla="*/ 43042 h 2975393"/>
+              </a:gdLst>
+              <a:ahLst/>
+              <a:cxnLst>
+                <a:cxn ang="0">
+                  <a:pos x="csX0" y="csY0"/>
+                </a:cxn>
+                <a:cxn ang="0">
+                  <a:pos x="csX1" y="csY1"/>
+                </a:cxn>
+                <a:cxn ang="0">
+                  <a:pos x="csX2" y="csY2"/>
+                </a:cxn>
+                <a:cxn ang="0">
+                  <a:pos x="csX3" y="csY3"/>
+                </a:cxn>
+                <a:cxn ang="0">
+                  <a:pos x="csX4" y="csY4"/>
+                </a:cxn>
+                <a:cxn ang="0">
+                  <a:pos x="csX5" y="csY5"/>
+                </a:cxn>
+                <a:cxn ang="0">
+                  <a:pos x="csX6" y="csY6"/>
+                </a:cxn>
+                <a:cxn ang="0">
+                  <a:pos x="csX7" y="csY7"/>
+                </a:cxn>
+                <a:cxn ang="0">
+                  <a:pos x="csX8" y="csY8"/>
+                </a:cxn>
+                <a:cxn ang="0">
+                  <a:pos x="csX9" y="csY9"/>
+                </a:cxn>
+                <a:cxn ang="0">
+                  <a:pos x="csX10" y="csY10"/>
+                </a:cxn>
+                <a:cxn ang="0">
+                  <a:pos x="csX11" y="csY11"/>
+                </a:cxn>
+                <a:cxn ang="0">
+                  <a:pos x="csX12" y="csY12"/>
+                </a:cxn>
+                <a:cxn ang="0">
+                  <a:pos x="csX13" y="csY13"/>
+                </a:cxn>
+                <a:cxn ang="0">
+                  <a:pos x="csX14" y="csY14"/>
+                </a:cxn>
+                <a:cxn ang="0">
+                  <a:pos x="csX15" y="csY15"/>
+                </a:cxn>
+                <a:cxn ang="0">
+                  <a:pos x="csX16" y="csY16"/>
+                </a:cxn>
+                <a:cxn ang="0">
+                  <a:pos x="csX17" y="csY17"/>
+                </a:cxn>
+                <a:cxn ang="0">
+                  <a:pos x="csX18" y="csY18"/>
+                </a:cxn>
+                <a:cxn ang="0">
+                  <a:pos x="csX19" y="csY19"/>
+                </a:cxn>
+                <a:cxn ang="0">
+                  <a:pos x="csX20" y="csY20"/>
+                </a:cxn>
+                <a:cxn ang="0">
+                  <a:pos x="csX21" y="csY21"/>
+                </a:cxn>
+                <a:cxn ang="0">
+                  <a:pos x="csX22" y="csY22"/>
+                </a:cxn>
+                <a:cxn ang="0">
+                  <a:pos x="csX23" y="csY23"/>
+                </a:cxn>
+                <a:cxn ang="0">
+                  <a:pos x="csX24" y="csY24"/>
+                </a:cxn>
+                <a:cxn ang="0">
+                  <a:pos x="csX25" y="csY25"/>
+                </a:cxn>
+                <a:cxn ang="0">
+                  <a:pos x="csX26" y="csY26"/>
+                </a:cxn>
+                <a:cxn ang="0">
+                  <a:pos x="csX27" y="csY27"/>
+                </a:cxn>
+                <a:cxn ang="0">
+                  <a:pos x="csX28" y="csY28"/>
+                </a:cxn>
+                <a:cxn ang="0">
+                  <a:pos x="csX29" y="csY29"/>
+                </a:cxn>
+                <a:cxn ang="0">
+                  <a:pos x="csX30" y="csY30"/>
+                </a:cxn>
+                <a:cxn ang="0">
+                  <a:pos x="csX31" y="csY31"/>
+                </a:cxn>
+              </a:cxnLst>
+              <a:rect l="l" t="t" r="r" b="b"/>
+              <a:pathLst>
+                <a:path w="1859303" h="2975393">
+                  <a:moveTo>
+                    <a:pt x="1827440" y="1298000"/>
+                  </a:moveTo>
+                  <a:lnTo>
+                    <a:pt x="1819666" y="1346839"/>
+                  </a:lnTo>
+                  <a:cubicBezTo>
+                    <a:pt x="1713293" y="1902012"/>
+                    <a:pt x="1387282" y="2379150"/>
+                    <a:pt x="935553" y="2684332"/>
+                  </a:cubicBezTo>
+                  <a:lnTo>
+                    <a:pt x="778993" y="2779445"/>
+                  </a:lnTo>
+                  <a:lnTo>
+                    <a:pt x="776932" y="2765944"/>
+                  </a:lnTo>
+                  <a:lnTo>
+                    <a:pt x="842194" y="2730240"/>
+                  </a:lnTo>
+                  <a:cubicBezTo>
+                    <a:pt x="1310880" y="2449317"/>
+                    <a:pt x="1660350" y="1989936"/>
+                    <a:pt x="1796685" y="1446018"/>
+                  </a:cubicBezTo>
+                  <a:close/>
+                  <a:moveTo>
+                    <a:pt x="1834091" y="1256216"/>
+                  </a:moveTo>
+                  <a:lnTo>
+                    <a:pt x="1831097" y="1280400"/>
+                  </a:lnTo>
+                  <a:lnTo>
+                    <a:pt x="1827440" y="1298000"/>
+                  </a:lnTo>
+                  <a:close/>
+                  <a:moveTo>
+                    <a:pt x="1844827" y="1169487"/>
+                  </a:moveTo>
+                  <a:lnTo>
+                    <a:pt x="1840272" y="1217379"/>
+                  </a:lnTo>
+                  <a:lnTo>
+                    <a:pt x="1834091" y="1256216"/>
+                  </a:lnTo>
+                  <a:close/>
+                  <a:moveTo>
+                    <a:pt x="1635975" y="0"/>
+                  </a:moveTo>
+                  <a:lnTo>
+                    <a:pt x="1695052" y="122635"/>
+                  </a:lnTo>
+                  <a:cubicBezTo>
+                    <a:pt x="1800817" y="372693"/>
+                    <a:pt x="1859303" y="647617"/>
+                    <a:pt x="1859303" y="936202"/>
+                  </a:cubicBezTo>
+                  <a:cubicBezTo>
+                    <a:pt x="1859303" y="994821"/>
+                    <a:pt x="1856890" y="1052876"/>
+                    <a:pt x="1852158" y="1110274"/>
+                  </a:cubicBezTo>
+                  <a:lnTo>
+                    <a:pt x="1844827" y="1169487"/>
+                  </a:lnTo>
+                  <a:lnTo>
+                    <a:pt x="1852824" y="1085406"/>
+                  </a:lnTo>
+                  <a:cubicBezTo>
+                    <a:pt x="1855637" y="1041024"/>
+                    <a:pt x="1857065" y="996266"/>
+                    <a:pt x="1857065" y="951175"/>
+                  </a:cubicBezTo>
+                  <a:cubicBezTo>
+                    <a:pt x="1857065" y="879029"/>
+                    <a:pt x="1853410" y="807737"/>
+                    <a:pt x="1846274" y="737473"/>
+                  </a:cubicBezTo>
+                  <a:lnTo>
+                    <a:pt x="1834254" y="658710"/>
+                  </a:lnTo>
+                  <a:lnTo>
+                    <a:pt x="1677694" y="753822"/>
+                  </a:lnTo>
+                  <a:cubicBezTo>
+                    <a:pt x="1121719" y="1129431"/>
+                    <a:pt x="756181" y="1765517"/>
+                    <a:pt x="756181" y="2486979"/>
+                  </a:cubicBezTo>
+                  <a:cubicBezTo>
+                    <a:pt x="756181" y="2559125"/>
+                    <a:pt x="759837" y="2630418"/>
+                    <a:pt x="766972" y="2700681"/>
+                  </a:cubicBezTo>
+                  <a:lnTo>
+                    <a:pt x="776932" y="2765944"/>
+                  </a:lnTo>
+                  <a:lnTo>
+                    <a:pt x="698105" y="2809069"/>
+                  </a:lnTo>
+                  <a:cubicBezTo>
+                    <a:pt x="599787" y="2857928"/>
+                    <a:pt x="497077" y="2899272"/>
+                    <a:pt x="390724" y="2932351"/>
+                  </a:cubicBezTo>
+                  <a:lnTo>
+                    <a:pt x="223328" y="2975393"/>
+                  </a:lnTo>
+                  <a:lnTo>
+                    <a:pt x="164252" y="2852758"/>
+                  </a:lnTo>
+                  <a:cubicBezTo>
+                    <a:pt x="58486" y="2602700"/>
+                    <a:pt x="0" y="2327775"/>
+                    <a:pt x="0" y="2039190"/>
+                  </a:cubicBezTo>
+                  <a:cubicBezTo>
+                    <a:pt x="0" y="1101290"/>
+                    <a:pt x="617759" y="307674"/>
+                    <a:pt x="1468580" y="43042"/>
+                  </a:cubicBezTo>
+                  <a:close/>
+                </a:path>
+              </a:pathLst>
+            </a:custGeom>
+            <a:solidFill>
+              <a:srgbClr val="FFC000">
+                <a:alpha val="71084"/>
+              </a:srgbClr>
+            </a:solidFill>
+            <a:ln w="19050">
+              <a:noFill/>
+            </a:ln>
+          </p:spPr>
+          <p:style>
+            <a:lnRef idx="2">
+              <a:schemeClr val="accent1">
+                <a:shade val="15000"/>
+              </a:schemeClr>
+            </a:lnRef>
+            <a:fillRef idx="1">
+              <a:schemeClr val="accent1"/>
+            </a:fillRef>
+            <a:effectRef idx="0">
+              <a:schemeClr val="accent1"/>
+            </a:effectRef>
+            <a:fontRef idx="minor">
+              <a:schemeClr val="lt1"/>
+            </a:fontRef>
+          </p:style>
+          <p:txBody>
+            <a:bodyPr wrap="square" rtlCol="0" anchor="ctr">
+              <a:noAutofit/>
+            </a:bodyPr>
+            <a:lstStyle/>
+            <a:p>
+              <a:pPr algn="ctr"/>
+              <a:endParaRPr kumimoji="1" lang="ja-JP" altLang="en-US"/>
+            </a:p>
+          </p:txBody>
+        </p:sp>
+        <p:cxnSp>
+          <p:nvCxnSpPr>
+            <p:cNvPr id="3" name="直線矢印コネクタ 2">
+              <a:extLst>
+                <a:ext uri="{FF2B5EF4-FFF2-40B4-BE49-F238E27FC236}">
+                  <a16:creationId xmlns:a16="http://schemas.microsoft.com/office/drawing/2014/main" id="{8E50B84C-C853-4812-86F4-BEE7A900DD84}"/>
+                </a:ext>
+              </a:extLst>
+            </p:cNvPr>
+            <p:cNvCxnSpPr>
+              <a:cxnSpLocks/>
+            </p:cNvCxnSpPr>
+            <p:nvPr/>
+          </p:nvCxnSpPr>
+          <p:spPr>
+            <a:xfrm>
+              <a:off x="1320150" y="6216979"/>
+              <a:ext cx="9440777" cy="0"/>
+            </a:xfrm>
+            <a:prstGeom prst="straightConnector1">
+              <a:avLst/>
+            </a:prstGeom>
+            <a:ln w="28575">
+              <a:solidFill>
+                <a:schemeClr val="tx1"/>
+              </a:solidFill>
+              <a:tailEnd type="triangle"/>
+            </a:ln>
+          </p:spPr>
+          <p:style>
+            <a:lnRef idx="1">
+              <a:schemeClr val="accent1"/>
+            </a:lnRef>
+            <a:fillRef idx="0">
+              <a:schemeClr val="accent1"/>
+            </a:fillRef>
+            <a:effectRef idx="0">
+              <a:schemeClr val="accent1"/>
+            </a:effectRef>
+            <a:fontRef idx="minor">
+              <a:schemeClr val="tx1"/>
+            </a:fontRef>
+          </p:style>
+        </p:cxnSp>
+        <p:cxnSp>
+          <p:nvCxnSpPr>
+            <p:cNvPr id="4" name="直線矢印コネクタ 3">
+              <a:extLst>
+                <a:ext uri="{FF2B5EF4-FFF2-40B4-BE49-F238E27FC236}">
+                  <a16:creationId xmlns:a16="http://schemas.microsoft.com/office/drawing/2014/main" id="{628093D9-278A-1AAB-3DA9-73F8C9665EE3}"/>
+                </a:ext>
+              </a:extLst>
+            </p:cNvPr>
+            <p:cNvCxnSpPr>
+              <a:cxnSpLocks/>
+            </p:cNvCxnSpPr>
+            <p:nvPr/>
+          </p:nvCxnSpPr>
+          <p:spPr>
+            <a:xfrm flipV="1">
+              <a:off x="1320150" y="390293"/>
+              <a:ext cx="0" cy="5826686"/>
+            </a:xfrm>
+            <a:prstGeom prst="straightConnector1">
+              <a:avLst/>
+            </a:prstGeom>
+            <a:ln w="28575">
+              <a:solidFill>
+                <a:schemeClr val="tx1"/>
+              </a:solidFill>
+              <a:tailEnd type="triangle"/>
+            </a:ln>
+          </p:spPr>
+          <p:style>
+            <a:lnRef idx="1">
+              <a:schemeClr val="accent1"/>
+            </a:lnRef>
+            <a:fillRef idx="0">
+              <a:schemeClr val="accent1"/>
+            </a:fillRef>
+            <a:effectRef idx="0">
+              <a:schemeClr val="accent1"/>
+            </a:effectRef>
+            <a:fontRef idx="minor">
+              <a:schemeClr val="tx1"/>
+            </a:fontRef>
+          </p:style>
+        </p:cxnSp>
+        <p:sp>
+          <p:nvSpPr>
+            <p:cNvPr id="5" name="テキスト ボックス 4">
+              <a:extLst>
+                <a:ext uri="{FF2B5EF4-FFF2-40B4-BE49-F238E27FC236}">
+                  <a16:creationId xmlns:a16="http://schemas.microsoft.com/office/drawing/2014/main" id="{D1F0698F-591E-EF5D-E8ED-9BE194B5801E}"/>
+                </a:ext>
+              </a:extLst>
+            </p:cNvPr>
+            <p:cNvSpPr txBox="1"/>
+            <p:nvPr/>
+          </p:nvSpPr>
+          <p:spPr>
+            <a:xfrm>
+              <a:off x="9248061" y="6233395"/>
+              <a:ext cx="1512866" cy="461665"/>
+            </a:xfrm>
+            <a:prstGeom prst="rect">
+              <a:avLst/>
+            </a:prstGeom>
+            <a:noFill/>
+          </p:spPr>
+          <p:txBody>
+            <a:bodyPr wrap="square" rtlCol="0">
+              <a:spAutoFit/>
+            </a:bodyPr>
+            <a:lstStyle/>
+            <a:p>
+              <a:pPr algn="ctr"/>
+              <a:r>
+                <a:rPr kumimoji="1" lang="ja-JP" altLang="en-US" sz="2400">
+                  <a:latin typeface="Hiragino Kaku Gothic StdN W8" panose="020B0800000000000000" pitchFamily="34" charset="-128"/>
+                  <a:ea typeface="Hiragino Kaku Gothic StdN W8" panose="020B0800000000000000" pitchFamily="34" charset="-128"/>
+                </a:rPr>
+                <a:t>車関税率</a:t>
+              </a:r>
+            </a:p>
+          </p:txBody>
+        </p:sp>
+        <p:sp>
+          <p:nvSpPr>
+            <p:cNvPr id="6" name="テキスト ボックス 5">
+              <a:extLst>
+                <a:ext uri="{FF2B5EF4-FFF2-40B4-BE49-F238E27FC236}">
+                  <a16:creationId xmlns:a16="http://schemas.microsoft.com/office/drawing/2014/main" id="{BB4F823E-E516-E0B2-DE67-0126D2C4481D}"/>
+                </a:ext>
+              </a:extLst>
+            </p:cNvPr>
+            <p:cNvSpPr txBox="1"/>
+            <p:nvPr/>
+          </p:nvSpPr>
+          <p:spPr>
+            <a:xfrm>
+              <a:off x="766152" y="390292"/>
+              <a:ext cx="553998" cy="1323439"/>
+            </a:xfrm>
+            <a:prstGeom prst="rect">
+              <a:avLst/>
+            </a:prstGeom>
+            <a:noFill/>
+          </p:spPr>
+          <p:txBody>
+            <a:bodyPr vert="eaVert" wrap="none" rtlCol="0">
+              <a:spAutoFit/>
+            </a:bodyPr>
+            <a:lstStyle/>
+            <a:p>
+              <a:r>
+                <a:rPr kumimoji="1" lang="ja-JP" altLang="en-US" sz="2400">
+                  <a:latin typeface="Hiragino Kaku Gothic StdN W8" panose="020B0800000000000000" pitchFamily="34" charset="-128"/>
+                  <a:ea typeface="Hiragino Kaku Gothic StdN W8" panose="020B0800000000000000" pitchFamily="34" charset="-128"/>
+                </a:rPr>
+                <a:t>肉関税率</a:t>
+              </a:r>
+            </a:p>
+          </p:txBody>
+        </p:sp>
+        <p:sp>
+          <p:nvSpPr>
+            <p:cNvPr id="15" name="円/楕円 14">
+              <a:extLst>
+                <a:ext uri="{FF2B5EF4-FFF2-40B4-BE49-F238E27FC236}">
+                  <a16:creationId xmlns:a16="http://schemas.microsoft.com/office/drawing/2014/main" id="{D20B4CFD-2820-11E1-B86C-3652D7098355}"/>
+                </a:ext>
+              </a:extLst>
+            </p:cNvPr>
+            <p:cNvSpPr/>
+            <p:nvPr/>
+          </p:nvSpPr>
+          <p:spPr>
+            <a:xfrm>
+              <a:off x="4369695" y="2364273"/>
+              <a:ext cx="186550" cy="186550"/>
+            </a:xfrm>
+            <a:prstGeom prst="ellipse">
+              <a:avLst/>
+            </a:prstGeom>
+            <a:solidFill>
+              <a:schemeClr val="tx1"/>
+            </a:solidFill>
+            <a:ln>
+              <a:noFill/>
+            </a:ln>
+          </p:spPr>
+          <p:style>
+            <a:lnRef idx="2">
+              <a:schemeClr val="accent1">
+                <a:shade val="50000"/>
+              </a:schemeClr>
+            </a:lnRef>
+            <a:fillRef idx="1">
+              <a:schemeClr val="accent1"/>
+            </a:fillRef>
+            <a:effectRef idx="0">
+              <a:schemeClr val="accent1"/>
+            </a:effectRef>
+            <a:fontRef idx="minor">
+              <a:schemeClr val="lt1"/>
+            </a:fontRef>
+          </p:style>
+          <p:txBody>
+            <a:bodyPr rtlCol="0" anchor="ctr"/>
+            <a:lstStyle/>
+            <a:p>
+              <a:pPr algn="ctr"/>
+              <a:endParaRPr kumimoji="1" lang="ja-JP" altLang="en-US"/>
+            </a:p>
+          </p:txBody>
+        </p:sp>
+        <p:sp>
+          <p:nvSpPr>
+            <p:cNvPr id="16" name="テキスト ボックス 15">
+              <a:extLst>
+                <a:ext uri="{FF2B5EF4-FFF2-40B4-BE49-F238E27FC236}">
+                  <a16:creationId xmlns:a16="http://schemas.microsoft.com/office/drawing/2014/main" id="{5B91290B-4C95-58E8-2E33-83272CC00089}"/>
+                </a:ext>
+              </a:extLst>
+            </p:cNvPr>
+            <p:cNvSpPr txBox="1"/>
+            <p:nvPr/>
+          </p:nvSpPr>
+          <p:spPr>
+            <a:xfrm>
+              <a:off x="3915337" y="2558199"/>
+              <a:ext cx="1024577" cy="461665"/>
+            </a:xfrm>
+            <a:prstGeom prst="rect">
+              <a:avLst/>
+            </a:prstGeom>
+            <a:noFill/>
+          </p:spPr>
+          <p:txBody>
+            <a:bodyPr wrap="square" rtlCol="0">
+              <a:spAutoFit/>
+            </a:bodyPr>
+            <a:lstStyle/>
+            <a:p>
+              <a:pPr algn="ctr"/>
+              <a:r>
+                <a:rPr kumimoji="1" lang="ja-JP" altLang="en-US" sz="2400">
+                  <a:latin typeface="Hiragino Kaku Gothic StdN W8" panose="020B0800000000000000" pitchFamily="34" charset="-128"/>
+                  <a:ea typeface="Hiragino Kaku Gothic StdN W8" panose="020B0800000000000000" pitchFamily="34" charset="-128"/>
+                </a:rPr>
+                <a:t>日本</a:t>
+              </a:r>
+            </a:p>
+          </p:txBody>
+        </p:sp>
+        <p:sp>
+          <p:nvSpPr>
+            <p:cNvPr id="17" name="円/楕円 16">
+              <a:extLst>
+                <a:ext uri="{FF2B5EF4-FFF2-40B4-BE49-F238E27FC236}">
+                  <a16:creationId xmlns:a16="http://schemas.microsoft.com/office/drawing/2014/main" id="{91219053-A682-2395-1220-FAF897F6001D}"/>
+                </a:ext>
+              </a:extLst>
+            </p:cNvPr>
+            <p:cNvSpPr/>
+            <p:nvPr/>
+          </p:nvSpPr>
+          <p:spPr>
+            <a:xfrm>
+              <a:off x="2354479" y="390292"/>
+              <a:ext cx="4180231" cy="4180231"/>
+            </a:xfrm>
+            <a:prstGeom prst="ellipse">
+              <a:avLst/>
+            </a:prstGeom>
+            <a:noFill/>
+            <a:ln w="19050">
+              <a:solidFill>
+                <a:schemeClr val="tx1"/>
+              </a:solidFill>
+            </a:ln>
+          </p:spPr>
+          <p:style>
+            <a:lnRef idx="2">
+              <a:schemeClr val="accent1">
+                <a:shade val="15000"/>
+              </a:schemeClr>
+            </a:lnRef>
+            <a:fillRef idx="1">
+              <a:schemeClr val="accent1"/>
+            </a:fillRef>
+            <a:effectRef idx="0">
+              <a:schemeClr val="accent1"/>
+            </a:effectRef>
+            <a:fontRef idx="minor">
+              <a:schemeClr val="lt1"/>
+            </a:fontRef>
+          </p:style>
+          <p:txBody>
+            <a:bodyPr rtlCol="0" anchor="ctr"/>
+            <a:lstStyle/>
+            <a:p>
+              <a:pPr algn="ctr"/>
+              <a:endParaRPr kumimoji="1" lang="ja-JP" altLang="en-US"/>
+            </a:p>
+          </p:txBody>
+        </p:sp>
+        <p:sp>
+          <p:nvSpPr>
+            <p:cNvPr id="12" name="テキスト ボックス 11">
+              <a:extLst>
+                <a:ext uri="{FF2B5EF4-FFF2-40B4-BE49-F238E27FC236}">
+                  <a16:creationId xmlns:a16="http://schemas.microsoft.com/office/drawing/2014/main" id="{2EE82621-0CE9-0A3A-8CD5-0EDA64DFA946}"/>
+                </a:ext>
+              </a:extLst>
+            </p:cNvPr>
+            <p:cNvSpPr txBox="1"/>
+            <p:nvPr/>
+          </p:nvSpPr>
+          <p:spPr>
+            <a:xfrm>
+              <a:off x="6996337" y="4091460"/>
+              <a:ext cx="1024577" cy="461665"/>
+            </a:xfrm>
+            <a:prstGeom prst="rect">
+              <a:avLst/>
+            </a:prstGeom>
+            <a:noFill/>
+          </p:spPr>
+          <p:txBody>
+            <a:bodyPr wrap="square" rtlCol="0">
+              <a:spAutoFit/>
+            </a:bodyPr>
+            <a:lstStyle/>
+            <a:p>
+              <a:r>
+                <a:rPr kumimoji="1" lang="ja-JP" altLang="en-US" sz="2400">
+                  <a:solidFill>
+                    <a:schemeClr val="tx1">
+                      <a:alpha val="25000"/>
+                    </a:schemeClr>
+                  </a:solidFill>
+                  <a:latin typeface="Hiragino Kaku Gothic StdN W8" panose="020B0800000000000000" pitchFamily="34" charset="-128"/>
+                  <a:ea typeface="Hiragino Kaku Gothic StdN W8" panose="020B0800000000000000" pitchFamily="34" charset="-128"/>
+                </a:rPr>
+                <a:t>米国</a:t>
+              </a:r>
+            </a:p>
+          </p:txBody>
+        </p:sp>
+        <p:sp>
+          <p:nvSpPr>
+            <p:cNvPr id="13" name="円/楕円 12">
+              <a:extLst>
+                <a:ext uri="{FF2B5EF4-FFF2-40B4-BE49-F238E27FC236}">
+                  <a16:creationId xmlns:a16="http://schemas.microsoft.com/office/drawing/2014/main" id="{98647350-4841-B76C-2D7F-F6C73FF326BA}"/>
+                </a:ext>
+              </a:extLst>
+            </p:cNvPr>
+            <p:cNvSpPr/>
+            <p:nvPr/>
+          </p:nvSpPr>
+          <p:spPr>
+            <a:xfrm>
+              <a:off x="7450695" y="3920436"/>
+              <a:ext cx="186550" cy="186550"/>
+            </a:xfrm>
+            <a:prstGeom prst="ellipse">
+              <a:avLst/>
+            </a:prstGeom>
+            <a:solidFill>
+              <a:schemeClr val="tx1">
+                <a:alpha val="30000"/>
+              </a:schemeClr>
+            </a:solidFill>
+            <a:ln>
+              <a:noFill/>
+            </a:ln>
+          </p:spPr>
+          <p:style>
+            <a:lnRef idx="2">
+              <a:schemeClr val="accent1">
+                <a:shade val="50000"/>
+              </a:schemeClr>
+            </a:lnRef>
+            <a:fillRef idx="1">
+              <a:schemeClr val="accent1"/>
+            </a:fillRef>
+            <a:effectRef idx="0">
+              <a:schemeClr val="accent1"/>
+            </a:effectRef>
+            <a:fontRef idx="minor">
+              <a:schemeClr val="lt1"/>
+            </a:fontRef>
+          </p:style>
+          <p:txBody>
+            <a:bodyPr rtlCol="0" anchor="ctr"/>
+            <a:lstStyle/>
+            <a:p>
+              <a:pPr algn="ctr"/>
+              <a:endParaRPr kumimoji="1" lang="ja-JP" altLang="en-US">
+                <a:solidFill>
+                  <a:schemeClr val="lt1">
+                    <a:alpha val="25000"/>
+                  </a:schemeClr>
+                </a:solidFill>
+              </a:endParaRPr>
+            </a:p>
+          </p:txBody>
+        </p:sp>
+        <p:sp>
+          <p:nvSpPr>
+            <p:cNvPr id="14" name="円/楕円 13">
+              <a:extLst>
+                <a:ext uri="{FF2B5EF4-FFF2-40B4-BE49-F238E27FC236}">
+                  <a16:creationId xmlns:a16="http://schemas.microsoft.com/office/drawing/2014/main" id="{82E29A12-C297-75F9-A376-5AD6BAF0347D}"/>
+                </a:ext>
+              </a:extLst>
+            </p:cNvPr>
+            <p:cNvSpPr/>
+            <p:nvPr/>
+          </p:nvSpPr>
+          <p:spPr>
+            <a:xfrm>
+              <a:off x="5433827" y="1926096"/>
+              <a:ext cx="4180231" cy="4180231"/>
+            </a:xfrm>
+            <a:prstGeom prst="ellipse">
+              <a:avLst/>
+            </a:prstGeom>
+            <a:noFill/>
+            <a:ln w="19050">
+              <a:solidFill>
+                <a:schemeClr val="tx1">
+                  <a:alpha val="29949"/>
+                </a:schemeClr>
+              </a:solidFill>
+            </a:ln>
+          </p:spPr>
+          <p:style>
+            <a:lnRef idx="2">
+              <a:schemeClr val="accent1">
+                <a:shade val="15000"/>
+              </a:schemeClr>
+            </a:lnRef>
+            <a:fillRef idx="1">
+              <a:schemeClr val="accent1"/>
+            </a:fillRef>
+            <a:effectRef idx="0">
+              <a:schemeClr val="accent1"/>
+            </a:effectRef>
+            <a:fontRef idx="minor">
+              <a:schemeClr val="lt1"/>
+            </a:fontRef>
+          </p:style>
+          <p:txBody>
+            <a:bodyPr rtlCol="0" anchor="ctr"/>
+            <a:lstStyle/>
+            <a:p>
+              <a:pPr algn="ctr"/>
+              <a:endParaRPr kumimoji="1" lang="ja-JP" altLang="en-US">
+                <a:solidFill>
+                  <a:schemeClr val="lt1">
+                    <a:alpha val="25000"/>
+                  </a:schemeClr>
+                </a:solidFill>
+              </a:endParaRPr>
+            </a:p>
+          </p:txBody>
+        </p:sp>
+        <p:sp>
+          <p:nvSpPr>
+            <p:cNvPr id="10" name="テキスト ボックス 9">
+              <a:extLst>
+                <a:ext uri="{FF2B5EF4-FFF2-40B4-BE49-F238E27FC236}">
+                  <a16:creationId xmlns:a16="http://schemas.microsoft.com/office/drawing/2014/main" id="{28E46E79-332D-2817-9451-247EB1EFAD89}"/>
+                </a:ext>
+              </a:extLst>
+            </p:cNvPr>
+            <p:cNvSpPr txBox="1"/>
+            <p:nvPr/>
+          </p:nvSpPr>
+          <p:spPr>
+            <a:xfrm>
+              <a:off x="6270771" y="1711020"/>
+              <a:ext cx="1024577" cy="461665"/>
+            </a:xfrm>
+            <a:prstGeom prst="rect">
+              <a:avLst/>
+            </a:prstGeom>
+            <a:noFill/>
+          </p:spPr>
+          <p:txBody>
+            <a:bodyPr wrap="square" rtlCol="0">
+              <a:spAutoFit/>
+            </a:bodyPr>
+            <a:lstStyle/>
+            <a:p>
+              <a:r>
+                <a:rPr kumimoji="1" lang="ja-JP" altLang="en-US" sz="2400">
+                  <a:latin typeface="Hiragino Kaku Gothic StdN W8" panose="020B0800000000000000" pitchFamily="34" charset="-128"/>
+                  <a:ea typeface="Hiragino Kaku Gothic StdN W8" panose="020B0800000000000000" pitchFamily="34" charset="-128"/>
+                </a:rPr>
+                <a:t>現状</a:t>
+              </a:r>
+            </a:p>
+          </p:txBody>
+        </p:sp>
+        <p:sp>
+          <p:nvSpPr>
+            <p:cNvPr id="11" name="円/楕円 10">
+              <a:extLst>
+                <a:ext uri="{FF2B5EF4-FFF2-40B4-BE49-F238E27FC236}">
+                  <a16:creationId xmlns:a16="http://schemas.microsoft.com/office/drawing/2014/main" id="{7D5E2134-9CD2-F121-E2B2-91CCE81015E3}"/>
+                </a:ext>
+              </a:extLst>
+            </p:cNvPr>
+            <p:cNvSpPr/>
+            <p:nvPr/>
+          </p:nvSpPr>
+          <p:spPr>
+            <a:xfrm>
+              <a:off x="6419541" y="2080078"/>
+              <a:ext cx="186550" cy="186550"/>
+            </a:xfrm>
+            <a:prstGeom prst="ellipse">
+              <a:avLst/>
+            </a:prstGeom>
+            <a:solidFill>
+              <a:schemeClr val="tx1"/>
+            </a:solidFill>
+            <a:ln>
+              <a:noFill/>
+            </a:ln>
+          </p:spPr>
+          <p:style>
+            <a:lnRef idx="2">
+              <a:schemeClr val="accent1">
+                <a:shade val="50000"/>
+              </a:schemeClr>
+            </a:lnRef>
+            <a:fillRef idx="1">
+              <a:schemeClr val="accent1"/>
+            </a:fillRef>
+            <a:effectRef idx="0">
+              <a:schemeClr val="accent1"/>
+            </a:effectRef>
+            <a:fontRef idx="minor">
+              <a:schemeClr val="lt1"/>
+            </a:fontRef>
+          </p:style>
+          <p:txBody>
+            <a:bodyPr rtlCol="0" anchor="ctr"/>
+            <a:lstStyle/>
+            <a:p>
+              <a:pPr algn="ctr"/>
+              <a:endParaRPr kumimoji="1" lang="ja-JP" altLang="en-US"/>
+            </a:p>
+          </p:txBody>
+        </p:sp>
+        <p:sp>
+          <p:nvSpPr>
+            <p:cNvPr id="19" name="テキスト ボックス 18">
+              <a:extLst>
+                <a:ext uri="{FF2B5EF4-FFF2-40B4-BE49-F238E27FC236}">
+                  <a16:creationId xmlns:a16="http://schemas.microsoft.com/office/drawing/2014/main" id="{897DCD65-BD94-6D54-72A4-D4EF2EA5BC28}"/>
+                </a:ext>
+              </a:extLst>
+            </p:cNvPr>
+            <p:cNvSpPr txBox="1"/>
+            <p:nvPr/>
+          </p:nvSpPr>
+          <p:spPr>
+            <a:xfrm>
+              <a:off x="6237918" y="3658644"/>
+              <a:ext cx="1024577" cy="461665"/>
+            </a:xfrm>
+            <a:prstGeom prst="rect">
+              <a:avLst/>
+            </a:prstGeom>
+            <a:noFill/>
+          </p:spPr>
+          <p:txBody>
+            <a:bodyPr wrap="square" rtlCol="0">
+              <a:spAutoFit/>
+            </a:bodyPr>
+            <a:lstStyle/>
+            <a:p>
+              <a:r>
+                <a:rPr kumimoji="1" lang="ja-JP" altLang="en-US" sz="2400">
+                  <a:latin typeface="Hiragino Kaku Gothic StdN W8" panose="020B0800000000000000" pitchFamily="34" charset="-128"/>
+                  <a:ea typeface="Hiragino Kaku Gothic StdN W8" panose="020B0800000000000000" pitchFamily="34" charset="-128"/>
+                </a:rPr>
+                <a:t>米国</a:t>
+              </a:r>
+              <a:r>
+                <a:rPr kumimoji="1" lang="en-US" altLang="ja-JP" sz="2400" dirty="0">
+                  <a:latin typeface="Hiragino Kaku Gothic StdN W8" panose="020B0800000000000000" pitchFamily="34" charset="-128"/>
+                  <a:ea typeface="Hiragino Kaku Gothic StdN W8" panose="020B0800000000000000" pitchFamily="34" charset="-128"/>
+                </a:rPr>
+                <a:t>’</a:t>
+              </a:r>
+              <a:endParaRPr kumimoji="1" lang="ja-JP" altLang="en-US" sz="2400">
+                <a:latin typeface="Hiragino Kaku Gothic StdN W8" panose="020B0800000000000000" pitchFamily="34" charset="-128"/>
+                <a:ea typeface="Hiragino Kaku Gothic StdN W8" panose="020B0800000000000000" pitchFamily="34" charset="-128"/>
+              </a:endParaRPr>
+            </a:p>
+          </p:txBody>
+        </p:sp>
+        <p:sp>
+          <p:nvSpPr>
+            <p:cNvPr id="20" name="円/楕円 19">
+              <a:extLst>
+                <a:ext uri="{FF2B5EF4-FFF2-40B4-BE49-F238E27FC236}">
+                  <a16:creationId xmlns:a16="http://schemas.microsoft.com/office/drawing/2014/main" id="{9833CFBC-6BBE-A6C0-25C8-C39967373FE3}"/>
+                </a:ext>
+              </a:extLst>
+            </p:cNvPr>
+            <p:cNvSpPr/>
+            <p:nvPr/>
+          </p:nvSpPr>
+          <p:spPr>
+            <a:xfrm>
+              <a:off x="6692276" y="3487620"/>
+              <a:ext cx="186550" cy="186550"/>
+            </a:xfrm>
+            <a:prstGeom prst="ellipse">
+              <a:avLst/>
+            </a:prstGeom>
+            <a:solidFill>
+              <a:schemeClr val="tx1"/>
+            </a:solidFill>
+            <a:ln>
+              <a:noFill/>
+            </a:ln>
+          </p:spPr>
+          <p:style>
+            <a:lnRef idx="2">
+              <a:schemeClr val="accent1">
+                <a:shade val="50000"/>
+              </a:schemeClr>
+            </a:lnRef>
+            <a:fillRef idx="1">
+              <a:schemeClr val="accent1"/>
+            </a:fillRef>
+            <a:effectRef idx="0">
+              <a:schemeClr val="accent1"/>
+            </a:effectRef>
+            <a:fontRef idx="minor">
+              <a:schemeClr val="lt1"/>
+            </a:fontRef>
+          </p:style>
+          <p:txBody>
+            <a:bodyPr rtlCol="0" anchor="ctr"/>
+            <a:lstStyle/>
+            <a:p>
+              <a:pPr algn="ctr"/>
+              <a:endParaRPr kumimoji="1" lang="ja-JP" altLang="en-US"/>
+            </a:p>
+          </p:txBody>
+        </p:sp>
+        <p:sp>
+          <p:nvSpPr>
+            <p:cNvPr id="21" name="円/楕円 20">
+              <a:extLst>
+                <a:ext uri="{FF2B5EF4-FFF2-40B4-BE49-F238E27FC236}">
+                  <a16:creationId xmlns:a16="http://schemas.microsoft.com/office/drawing/2014/main" id="{DFA29273-0D89-A1FD-A0FF-FD85E7D81973}"/>
+                </a:ext>
+              </a:extLst>
+            </p:cNvPr>
+            <p:cNvSpPr/>
+            <p:nvPr/>
+          </p:nvSpPr>
+          <p:spPr>
+            <a:xfrm>
+              <a:off x="4675408" y="1493280"/>
+              <a:ext cx="4180231" cy="4180231"/>
+            </a:xfrm>
+            <a:prstGeom prst="ellipse">
+              <a:avLst/>
+            </a:prstGeom>
+            <a:noFill/>
+            <a:ln w="19050">
+              <a:solidFill>
+                <a:schemeClr val="tx1"/>
+              </a:solidFill>
+            </a:ln>
+          </p:spPr>
+          <p:style>
+            <a:lnRef idx="2">
+              <a:schemeClr val="accent1">
+                <a:shade val="15000"/>
+              </a:schemeClr>
+            </a:lnRef>
+            <a:fillRef idx="1">
+              <a:schemeClr val="accent1"/>
+            </a:fillRef>
+            <a:effectRef idx="0">
+              <a:schemeClr val="accent1"/>
+            </a:effectRef>
+            <a:fontRef idx="minor">
+              <a:schemeClr val="lt1"/>
+            </a:fontRef>
+          </p:style>
+          <p:txBody>
+            <a:bodyPr rtlCol="0" anchor="ctr"/>
+            <a:lstStyle/>
+            <a:p>
+              <a:pPr algn="ctr"/>
+              <a:endParaRPr kumimoji="1" lang="ja-JP" altLang="en-US"/>
+            </a:p>
+          </p:txBody>
+        </p:sp>
+        <p:sp>
+          <p:nvSpPr>
+            <p:cNvPr id="32" name="フリーフォーム 31">
+              <a:extLst>
+                <a:ext uri="{FF2B5EF4-FFF2-40B4-BE49-F238E27FC236}">
+                  <a16:creationId xmlns:a16="http://schemas.microsoft.com/office/drawing/2014/main" id="{1EBBB627-C008-55C2-171F-20C48D9D8D3C}"/>
+                </a:ext>
+              </a:extLst>
+            </p:cNvPr>
+            <p:cNvSpPr/>
+            <p:nvPr/>
+          </p:nvSpPr>
+          <p:spPr>
+            <a:xfrm>
+              <a:off x="5440520" y="2209997"/>
+              <a:ext cx="1100884" cy="2120735"/>
+            </a:xfrm>
+            <a:custGeom>
+              <a:avLst/>
+              <a:gdLst>
+                <a:gd name="csX0" fmla="*/ 1078073 w 1100884"/>
+                <a:gd name="csY0" fmla="*/ 0 h 2120735"/>
+                <a:gd name="csX1" fmla="*/ 1090093 w 1100884"/>
+                <a:gd name="csY1" fmla="*/ 78763 h 2120735"/>
+                <a:gd name="csX2" fmla="*/ 1100884 w 1100884"/>
+                <a:gd name="csY2" fmla="*/ 292465 h 2120735"/>
+                <a:gd name="csX3" fmla="*/ 179372 w 1100884"/>
+                <a:gd name="csY3" fmla="*/ 2025622 h 2120735"/>
+                <a:gd name="csX4" fmla="*/ 22812 w 1100884"/>
+                <a:gd name="csY4" fmla="*/ 2120735 h 2120735"/>
+                <a:gd name="csX5" fmla="*/ 10791 w 1100884"/>
+                <a:gd name="csY5" fmla="*/ 2041971 h 2120735"/>
+                <a:gd name="csX6" fmla="*/ 0 w 1100884"/>
+                <a:gd name="csY6" fmla="*/ 1828269 h 2120735"/>
+                <a:gd name="csX7" fmla="*/ 921513 w 1100884"/>
+                <a:gd name="csY7" fmla="*/ 95112 h 2120735"/>
+              </a:gdLst>
+              <a:ahLst/>
+              <a:cxnLst>
+                <a:cxn ang="0">
+                  <a:pos x="csX0" y="csY0"/>
+                </a:cxn>
+                <a:cxn ang="0">
+                  <a:pos x="csX1" y="csY1"/>
+                </a:cxn>
+                <a:cxn ang="0">
+                  <a:pos x="csX2" y="csY2"/>
+                </a:cxn>
+                <a:cxn ang="0">
+                  <a:pos x="csX3" y="csY3"/>
+                </a:cxn>
+                <a:cxn ang="0">
+                  <a:pos x="csX4" y="csY4"/>
+                </a:cxn>
+                <a:cxn ang="0">
+                  <a:pos x="csX5" y="csY5"/>
+                </a:cxn>
+                <a:cxn ang="0">
+                  <a:pos x="csX6" y="csY6"/>
+                </a:cxn>
+                <a:cxn ang="0">
+                  <a:pos x="csX7" y="csY7"/>
+                </a:cxn>
+              </a:cxnLst>
+              <a:rect l="l" t="t" r="r" b="b"/>
+              <a:pathLst>
+                <a:path w="1100884" h="2120735">
+                  <a:moveTo>
+                    <a:pt x="1078073" y="0"/>
+                  </a:moveTo>
+                  <a:lnTo>
+                    <a:pt x="1090093" y="78763"/>
+                  </a:lnTo>
+                  <a:cubicBezTo>
+                    <a:pt x="1097229" y="149027"/>
+                    <a:pt x="1100884" y="220319"/>
+                    <a:pt x="1100884" y="292465"/>
+                  </a:cubicBezTo>
+                  <a:cubicBezTo>
+                    <a:pt x="1100884" y="1013927"/>
+                    <a:pt x="735346" y="1650013"/>
+                    <a:pt x="179372" y="2025622"/>
+                  </a:cubicBezTo>
+                  <a:lnTo>
+                    <a:pt x="22812" y="2120735"/>
+                  </a:lnTo>
+                  <a:lnTo>
+                    <a:pt x="10791" y="2041971"/>
+                  </a:lnTo>
+                  <a:cubicBezTo>
+                    <a:pt x="3656" y="1971708"/>
+                    <a:pt x="0" y="1900415"/>
+                    <a:pt x="0" y="1828269"/>
+                  </a:cubicBezTo>
+                  <a:cubicBezTo>
+                    <a:pt x="0" y="1106807"/>
+                    <a:pt x="365538" y="470721"/>
+                    <a:pt x="921513" y="95112"/>
+                  </a:cubicBezTo>
+                  <a:close/>
+                </a:path>
+              </a:pathLst>
+            </a:custGeom>
+            <a:solidFill>
+              <a:srgbClr val="FF0000">
+                <a:alpha val="30000"/>
+              </a:srgbClr>
+            </a:solidFill>
+            <a:ln w="19050">
+              <a:noFill/>
+            </a:ln>
+          </p:spPr>
+          <p:style>
+            <a:lnRef idx="2">
+              <a:schemeClr val="accent1">
+                <a:shade val="15000"/>
+              </a:schemeClr>
+            </a:lnRef>
+            <a:fillRef idx="1">
+              <a:schemeClr val="accent1"/>
+            </a:fillRef>
+            <a:effectRef idx="0">
+              <a:schemeClr val="accent1"/>
+            </a:effectRef>
+            <a:fontRef idx="minor">
+              <a:schemeClr val="lt1"/>
+            </a:fontRef>
+          </p:style>
+          <p:txBody>
+            <a:bodyPr wrap="square" rtlCol="0" anchor="ctr">
+              <a:noAutofit/>
+            </a:bodyPr>
+            <a:lstStyle/>
+            <a:p>
+              <a:pPr algn="ctr"/>
+              <a:endParaRPr kumimoji="1" lang="ja-JP" altLang="en-US"/>
+            </a:p>
+          </p:txBody>
+        </p:sp>
+        <p:sp>
+          <p:nvSpPr>
+            <p:cNvPr id="45" name="フリーフォーム 44">
+              <a:extLst>
+                <a:ext uri="{FF2B5EF4-FFF2-40B4-BE49-F238E27FC236}">
+                  <a16:creationId xmlns:a16="http://schemas.microsoft.com/office/drawing/2014/main" id="{47FF85BA-74E9-0166-697C-EBA1B6F213E8}"/>
+                </a:ext>
+              </a:extLst>
+            </p:cNvPr>
+            <p:cNvSpPr/>
+            <p:nvPr/>
+          </p:nvSpPr>
+          <p:spPr>
+            <a:xfrm>
+              <a:off x="4675408" y="1544206"/>
+              <a:ext cx="1859303" cy="2975393"/>
+            </a:xfrm>
+            <a:custGeom>
+              <a:avLst/>
+              <a:gdLst>
+                <a:gd name="csX0" fmla="*/ 1635975 w 1859303"/>
+                <a:gd name="csY0" fmla="*/ 0 h 2975393"/>
+                <a:gd name="csX1" fmla="*/ 1695052 w 1859303"/>
+                <a:gd name="csY1" fmla="*/ 122635 h 2975393"/>
+                <a:gd name="csX2" fmla="*/ 1859303 w 1859303"/>
+                <a:gd name="csY2" fmla="*/ 936202 h 2975393"/>
+                <a:gd name="csX3" fmla="*/ 390724 w 1859303"/>
+                <a:gd name="csY3" fmla="*/ 2932351 h 2975393"/>
+                <a:gd name="csX4" fmla="*/ 223328 w 1859303"/>
+                <a:gd name="csY4" fmla="*/ 2975393 h 2975393"/>
+                <a:gd name="csX5" fmla="*/ 164252 w 1859303"/>
+                <a:gd name="csY5" fmla="*/ 2852758 h 2975393"/>
+                <a:gd name="csX6" fmla="*/ 0 w 1859303"/>
+                <a:gd name="csY6" fmla="*/ 2039190 h 2975393"/>
+                <a:gd name="csX7" fmla="*/ 1468580 w 1859303"/>
+                <a:gd name="csY7" fmla="*/ 43042 h 2975393"/>
+              </a:gdLst>
+              <a:ahLst/>
+              <a:cxnLst>
+                <a:cxn ang="0">
+                  <a:pos x="csX0" y="csY0"/>
+                </a:cxn>
+                <a:cxn ang="0">
+                  <a:pos x="csX1" y="csY1"/>
+                </a:cxn>
+                <a:cxn ang="0">
+                  <a:pos x="csX2" y="csY2"/>
+                </a:cxn>
+                <a:cxn ang="0">
+                  <a:pos x="csX3" y="csY3"/>
+                </a:cxn>
+                <a:cxn ang="0">
+                  <a:pos x="csX4" y="csY4"/>
+                </a:cxn>
+                <a:cxn ang="0">
+                  <a:pos x="csX5" y="csY5"/>
+                </a:cxn>
+                <a:cxn ang="0">
+                  <a:pos x="csX6" y="csY6"/>
+                </a:cxn>
+                <a:cxn ang="0">
+                  <a:pos x="csX7" y="csY7"/>
+                </a:cxn>
+              </a:cxnLst>
+              <a:rect l="l" t="t" r="r" b="b"/>
+              <a:pathLst>
+                <a:path w="1859303" h="2975393">
+                  <a:moveTo>
+                    <a:pt x="1635975" y="0"/>
+                  </a:moveTo>
+                  <a:lnTo>
+                    <a:pt x="1695052" y="122635"/>
+                  </a:lnTo>
+                  <a:cubicBezTo>
+                    <a:pt x="1800817" y="372693"/>
+                    <a:pt x="1859303" y="647617"/>
+                    <a:pt x="1859303" y="936202"/>
+                  </a:cubicBezTo>
+                  <a:cubicBezTo>
+                    <a:pt x="1859303" y="1874103"/>
+                    <a:pt x="1241544" y="2667718"/>
+                    <a:pt x="390724" y="2932351"/>
+                  </a:cubicBezTo>
+                  <a:lnTo>
+                    <a:pt x="223328" y="2975393"/>
+                  </a:lnTo>
+                  <a:lnTo>
+                    <a:pt x="164252" y="2852758"/>
+                  </a:lnTo>
+                  <a:cubicBezTo>
+                    <a:pt x="58486" y="2602700"/>
+                    <a:pt x="0" y="2327775"/>
+                    <a:pt x="0" y="2039190"/>
+                  </a:cubicBezTo>
+                  <a:cubicBezTo>
+                    <a:pt x="0" y="1101290"/>
+                    <a:pt x="617759" y="307674"/>
+                    <a:pt x="1468580" y="43042"/>
+                  </a:cubicBezTo>
+                  <a:close/>
+                </a:path>
+              </a:pathLst>
+            </a:custGeom>
+            <a:noFill/>
+            <a:ln w="19050">
+              <a:solidFill>
+                <a:schemeClr val="tx1"/>
+              </a:solidFill>
+            </a:ln>
+          </p:spPr>
+          <p:style>
+            <a:lnRef idx="2">
+              <a:schemeClr val="accent1">
+                <a:shade val="15000"/>
+              </a:schemeClr>
+            </a:lnRef>
+            <a:fillRef idx="1">
+              <a:schemeClr val="accent1"/>
+            </a:fillRef>
+            <a:effectRef idx="0">
+              <a:schemeClr val="accent1"/>
+            </a:effectRef>
+            <a:fontRef idx="minor">
+              <a:schemeClr val="lt1"/>
+            </a:fontRef>
+          </p:style>
+          <p:txBody>
+            <a:bodyPr wrap="square" rtlCol="0" anchor="ctr">
+              <a:noAutofit/>
+            </a:bodyPr>
+            <a:lstStyle/>
+            <a:p>
+              <a:pPr algn="ctr"/>
+              <a:endParaRPr kumimoji="1" lang="ja-JP" altLang="en-US"/>
+            </a:p>
+          </p:txBody>
+        </p:sp>
+        <p:cxnSp>
+          <p:nvCxnSpPr>
+            <p:cNvPr id="53" name="直線矢印コネクタ 52">
+              <a:extLst>
+                <a:ext uri="{FF2B5EF4-FFF2-40B4-BE49-F238E27FC236}">
+                  <a16:creationId xmlns:a16="http://schemas.microsoft.com/office/drawing/2014/main" id="{3398C511-889B-B909-07E1-A24AA66861FE}"/>
+                </a:ext>
+              </a:extLst>
+            </p:cNvPr>
+            <p:cNvCxnSpPr>
+              <a:cxnSpLocks/>
+              <a:stCxn id="13" idx="1"/>
+              <a:endCxn id="20" idx="6"/>
+            </p:cNvCxnSpPr>
+            <p:nvPr/>
+          </p:nvCxnSpPr>
+          <p:spPr>
+            <a:xfrm flipH="1" flipV="1">
+              <a:off x="6878826" y="3580895"/>
+              <a:ext cx="599189" cy="366861"/>
+            </a:xfrm>
+            <a:prstGeom prst="straightConnector1">
+              <a:avLst/>
+            </a:prstGeom>
+            <a:ln w="57150">
+              <a:solidFill>
+                <a:schemeClr val="tx1"/>
+              </a:solidFill>
+              <a:tailEnd type="triangle"/>
+            </a:ln>
+          </p:spPr>
+          <p:style>
+            <a:lnRef idx="1">
+              <a:schemeClr val="accent1"/>
+            </a:lnRef>
+            <a:fillRef idx="0">
+              <a:schemeClr val="accent1"/>
+            </a:fillRef>
+            <a:effectRef idx="0">
+              <a:schemeClr val="accent1"/>
+            </a:effectRef>
+            <a:fontRef idx="minor">
+              <a:schemeClr val="tx1"/>
+            </a:fontRef>
+          </p:style>
+        </p:cxnSp>
+      </p:grpSp>
+    </p:spTree>
+    <p:extLst>
+      <p:ext uri="{BB962C8B-B14F-4D97-AF65-F5344CB8AC3E}">
+        <p14:creationId xmlns:p14="http://schemas.microsoft.com/office/powerpoint/2010/main" val="1593770684"/>
+      </p:ext>
+    </p:extLst>
+  </p:cSld>
+  <p:clrMapOvr>
+    <a:masterClrMapping/>
+  </p:clrMapOvr>
+</p:sld>
+</file>
+
 <file path=ppt/theme/theme1.xml><?xml version="1.0" encoding="utf-8"?>
 <a:theme xmlns:a="http://schemas.openxmlformats.org/drawingml/2006/main" name="Office テーマ">
   <a:themeElements>

</xml_diff>